<commit_message>
refresh executed outputs across all 7 notebooks
End-to-end pipeline re-run confirms every notebook executes cleanly
(exit code 0) on the current data. No code changes, only re-executed
cell outputs. deck/WITH_RESULTS.pptx also touched (PowerPoint
metadata refresh).
</commit_message>
<xml_diff>
--- a/deck/Ergonomic_Risk_Factor_Prediction_Project_Plan_WITH_RESULTS.pptx
+++ b/deck/Ergonomic_Risk_Factor_Prediction_Project_Plan_WITH_RESULTS.pptx
@@ -43,21 +43,21 @@
     <p:sldId id="302" r:id="rId37"/>
     <p:sldId id="295" r:id="rId38"/>
     <p:sldId id="275" r:id="rId39"/>
-    <p:sldId id="303" r:id="rId45"/>
-    <p:sldId id="304" r:id="rId46"/>
-    <p:sldId id="305" r:id="rId47"/>
-    <p:sldId id="306" r:id="rId48"/>
-    <p:sldId id="307" r:id="rId49"/>
-    <p:sldId id="308" r:id="rId50"/>
-    <p:sldId id="309" r:id="rId51"/>
-    <p:sldId id="310" r:id="rId52"/>
-    <p:sldId id="311" r:id="rId53"/>
-    <p:sldId id="312" r:id="rId54"/>
-    <p:sldId id="313" r:id="rId55"/>
-    <p:sldId id="314" r:id="rId56"/>
-    <p:sldId id="315" r:id="rId57"/>
-    <p:sldId id="316" r:id="rId58"/>
-    <p:sldId id="301" r:id="rId40"/>
+    <p:sldId id="303" r:id="rId40"/>
+    <p:sldId id="304" r:id="rId41"/>
+    <p:sldId id="305" r:id="rId42"/>
+    <p:sldId id="306" r:id="rId43"/>
+    <p:sldId id="307" r:id="rId44"/>
+    <p:sldId id="308" r:id="rId45"/>
+    <p:sldId id="309" r:id="rId46"/>
+    <p:sldId id="310" r:id="rId47"/>
+    <p:sldId id="311" r:id="rId48"/>
+    <p:sldId id="312" r:id="rId49"/>
+    <p:sldId id="313" r:id="rId50"/>
+    <p:sldId id="314" r:id="rId51"/>
+    <p:sldId id="315" r:id="rId52"/>
+    <p:sldId id="316" r:id="rId53"/>
+    <p:sldId id="301" r:id="rId54"/>
   </p:sldIdLst>
   <p:sldSz cx="12192000" cy="6858000"/>
   <p:notesSz cx="6858000" cy="9144000"/>
@@ -354,7 +354,7 @@
           <a:p>
             <a:fld id="{5BCAD085-E8A6-8845-BD4E-CB4CCA059FC4}" type="datetimeFigureOut">
               <a:rPr lang="en-US" smtClean="0"/>
-              <a:t>27-May-26</a:t>
+              <a:t>22-Jun-26</a:t>
             </a:fld>
             <a:endParaRPr lang="en-US"/>
           </a:p>
@@ -522,7 +522,7 @@
           <a:p>
             <a:fld id="{5BCAD085-E8A6-8845-BD4E-CB4CCA059FC4}" type="datetimeFigureOut">
               <a:rPr lang="en-US" smtClean="0"/>
-              <a:t>27-May-26</a:t>
+              <a:t>22-Jun-26</a:t>
             </a:fld>
             <a:endParaRPr lang="en-US"/>
           </a:p>
@@ -700,7 +700,7 @@
           <a:p>
             <a:fld id="{5BCAD085-E8A6-8845-BD4E-CB4CCA059FC4}" type="datetimeFigureOut">
               <a:rPr lang="en-US" smtClean="0"/>
-              <a:t>27-May-26</a:t>
+              <a:t>22-Jun-26</a:t>
             </a:fld>
             <a:endParaRPr lang="en-US"/>
           </a:p>
@@ -870,7 +870,7 @@
           <a:p>
             <a:fld id="{5BCAD085-E8A6-8845-BD4E-CB4CCA059FC4}" type="datetimeFigureOut">
               <a:rPr lang="en-US" smtClean="0"/>
-              <a:t>27-May-26</a:t>
+              <a:t>22-Jun-26</a:t>
             </a:fld>
             <a:endParaRPr lang="en-US"/>
           </a:p>
@@ -1144,7 +1144,7 @@
           <a:p>
             <a:fld id="{5BCAD085-E8A6-8845-BD4E-CB4CCA059FC4}" type="datetimeFigureOut">
               <a:rPr lang="en-US" smtClean="0"/>
-              <a:t>27-May-26</a:t>
+              <a:t>22-Jun-26</a:t>
             </a:fld>
             <a:endParaRPr lang="en-US"/>
           </a:p>
@@ -1429,7 +1429,7 @@
           <a:p>
             <a:fld id="{5BCAD085-E8A6-8845-BD4E-CB4CCA059FC4}" type="datetimeFigureOut">
               <a:rPr lang="en-US" smtClean="0"/>
-              <a:t>27-May-26</a:t>
+              <a:t>22-Jun-26</a:t>
             </a:fld>
             <a:endParaRPr lang="en-US"/>
           </a:p>
@@ -1848,7 +1848,7 @@
           <a:p>
             <a:fld id="{5BCAD085-E8A6-8845-BD4E-CB4CCA059FC4}" type="datetimeFigureOut">
               <a:rPr lang="en-US" smtClean="0"/>
-              <a:t>27-May-26</a:t>
+              <a:t>22-Jun-26</a:t>
             </a:fld>
             <a:endParaRPr lang="en-US"/>
           </a:p>
@@ -1965,7 +1965,7 @@
           <a:p>
             <a:fld id="{5BCAD085-E8A6-8845-BD4E-CB4CCA059FC4}" type="datetimeFigureOut">
               <a:rPr lang="en-US" smtClean="0"/>
-              <a:t>27-May-26</a:t>
+              <a:t>22-Jun-26</a:t>
             </a:fld>
             <a:endParaRPr lang="en-US"/>
           </a:p>
@@ -2060,7 +2060,7 @@
           <a:p>
             <a:fld id="{5BCAD085-E8A6-8845-BD4E-CB4CCA059FC4}" type="datetimeFigureOut">
               <a:rPr lang="en-US" smtClean="0"/>
-              <a:t>27-May-26</a:t>
+              <a:t>22-Jun-26</a:t>
             </a:fld>
             <a:endParaRPr lang="en-US"/>
           </a:p>
@@ -2335,7 +2335,7 @@
           <a:p>
             <a:fld id="{5BCAD085-E8A6-8845-BD4E-CB4CCA059FC4}" type="datetimeFigureOut">
               <a:rPr lang="en-US" smtClean="0"/>
-              <a:t>27-May-26</a:t>
+              <a:t>22-Jun-26</a:t>
             </a:fld>
             <a:endParaRPr lang="en-US"/>
           </a:p>
@@ -2587,7 +2587,7 @@
           <a:p>
             <a:fld id="{5BCAD085-E8A6-8845-BD4E-CB4CCA059FC4}" type="datetimeFigureOut">
               <a:rPr lang="en-US" smtClean="0"/>
-              <a:t>27-May-26</a:t>
+              <a:t>22-Jun-26</a:t>
             </a:fld>
             <a:endParaRPr lang="en-US"/>
           </a:p>
@@ -2798,7 +2798,7 @@
           <a:p>
             <a:fld id="{5BCAD085-E8A6-8845-BD4E-CB4CCA059FC4}" type="datetimeFigureOut">
               <a:rPr lang="en-US" smtClean="0"/>
-              <a:t>27-May-26</a:t>
+              <a:t>22-Jun-26</a:t>
             </a:fld>
             <a:endParaRPr lang="en-US"/>
           </a:p>
@@ -9063,13 +9063,7 @@
   <p:cSld>
     <p:spTree>
       <p:nvGrpSpPr>
-        <p:cNvPr id="1" name="">
-          <a:extLst>
-            <a:ext uri="{FF2B5EF4-FFF2-40B4-BE49-F238E27FC236}">
-              <a16:creationId xmlns:a16="http://schemas.microsoft.com/office/drawing/2014/main" id="{D37942D0-0D70-589E-4C8C-483BF92661B5}"/>
-            </a:ext>
-          </a:extLst>
-        </p:cNvPr>
+        <p:cNvPr id="1" name=""/>
         <p:cNvGrpSpPr/>
         <p:nvPr/>
       </p:nvGrpSpPr>
@@ -9083,13 +9077,7 @@
       </p:grpSpPr>
       <p:sp>
         <p:nvSpPr>
-          <p:cNvPr id="2" name="Title 1">
-            <a:extLst>
-              <a:ext uri="{FF2B5EF4-FFF2-40B4-BE49-F238E27FC236}">
-                <a16:creationId xmlns:a16="http://schemas.microsoft.com/office/drawing/2014/main" id="{9C745776-0702-1FE3-1C3F-291E63955224}"/>
-              </a:ext>
-            </a:extLst>
-          </p:cNvPr>
+          <p:cNvPr id="2" name="Title 1"/>
           <p:cNvSpPr>
             <a:spLocks noGrp="1"/>
           </p:cNvSpPr>
@@ -9097,31 +9085,39 @@
             <p:ph type="title"/>
           </p:nvPr>
         </p:nvSpPr>
-        <p:spPr>
-          <a:xfrm>
-            <a:off x="4774063" y="2857500"/>
-            <a:ext cx="2643873" cy="1143000"/>
-          </a:xfrm>
-        </p:spPr>
+        <p:spPr/>
         <p:txBody>
           <a:bodyPr/>
           <a:lstStyle/>
           <a:p>
-            <a:pPr algn="ctr"/>
-            <a:r>
-              <a:rPr lang="en-US" dirty="0"/>
-              <a:t>Thank You</a:t>
-            </a:r>
-            <a:endParaRPr dirty="0"/>
+            <a:r>
+              <a:t>Results &amp; Findings</a:t>
+            </a:r>
+          </a:p>
+        </p:txBody>
+      </p:sp>
+      <p:sp>
+        <p:nvSpPr>
+          <p:cNvPr id="3" name="Text Placeholder 2"/>
+          <p:cNvSpPr>
+            <a:spLocks noGrp="1"/>
+          </p:cNvSpPr>
+          <p:nvPr>
+            <p:ph type="body" idx="1"/>
+          </p:nvPr>
+        </p:nvSpPr>
+        <p:spPr/>
+        <p:txBody>
+          <a:bodyPr/>
+          <a:lstStyle/>
+          <a:p>
+            <a:r>
+              <a:t>Phase 4-7 outputs from the 182-rider sample</a:t>
+            </a:r>
           </a:p>
         </p:txBody>
       </p:sp>
     </p:spTree>
-    <p:extLst>
-      <p:ext uri="{BB962C8B-B14F-4D97-AF65-F5344CB8AC3E}">
-        <p14:creationId xmlns:p14="http://schemas.microsoft.com/office/powerpoint/2010/main" val="2503925356"/>
-      </p:ext>
-    </p:extLst>
   </p:cSld>
   <p:clrMapOvr>
     <a:masterClrMapping/>
@@ -9258,7 +9254,7 @@
 </file>
 
 <file path=ppt/slides/slide40.xml><?xml version="1.0" encoding="utf-8"?>
-<p:sld xmlns:a="http://schemas.openxmlformats.org/drawingml/2006/main" xmlns:p="http://schemas.openxmlformats.org/presentationml/2006/main" xmlns:r="http://schemas.openxmlformats.org/officeDocument/2006/relationships">
+<p:sld xmlns:a="http://schemas.openxmlformats.org/drawingml/2006/main" xmlns:r="http://schemas.openxmlformats.org/officeDocument/2006/relationships" xmlns:p="http://schemas.openxmlformats.org/presentationml/2006/main">
   <p:cSld>
     <p:spTree>
       <p:nvGrpSpPr>
@@ -9266,7 +9262,14 @@
         <p:cNvGrpSpPr/>
         <p:nvPr/>
       </p:nvGrpSpPr>
-      <p:grpSpPr/>
+      <p:grpSpPr>
+        <a:xfrm>
+          <a:off x="0" y="0"/>
+          <a:ext cx="0" cy="0"/>
+          <a:chOff x="0" y="0"/>
+          <a:chExt cx="0" cy="0"/>
+        </a:xfrm>
+      </p:grpSpPr>
       <p:sp>
         <p:nvSpPr>
           <p:cNvPr id="2" name="Title 1"/>
@@ -9283,66 +9286,7 @@
           <a:lstStyle/>
           <a:p>
             <a:r>
-              <a:t>Results &amp; Findings</a:t>
-            </a:r>
-          </a:p>
-        </p:txBody>
-      </p:sp>
-      <p:sp>
-        <p:nvSpPr>
-          <p:cNvPr id="3" name="Text Placeholder 2"/>
-          <p:cNvSpPr>
-            <a:spLocks noGrp="1"/>
-          </p:cNvSpPr>
-          <p:nvPr>
-            <p:ph type="body" idx="1"/>
-          </p:nvPr>
-        </p:nvSpPr>
-        <p:spPr/>
-        <p:txBody>
-          <a:bodyPr/>
-          <a:lstStyle/>
-          <a:p>
-            <a:r>
-              <a:t>Phase 4-7 outputs from the 182-rider sample</a:t>
-            </a:r>
-          </a:p>
-        </p:txBody>
-      </p:sp>
-    </p:spTree>
-  </p:cSld>
-  <p:clrMapOvr>
-    <a:masterClrMapping/>
-  </p:clrMapOvr>
-</p:sld>
-</file>
-
-<file path=ppt/slides/slide41.xml><?xml version="1.0" encoding="utf-8"?>
-<p:sld xmlns:a="http://schemas.openxmlformats.org/drawingml/2006/main" xmlns:p="http://schemas.openxmlformats.org/presentationml/2006/main" xmlns:r="http://schemas.openxmlformats.org/officeDocument/2006/relationships">
-  <p:cSld>
-    <p:spTree>
-      <p:nvGrpSpPr>
-        <p:cNvPr id="1" name=""/>
-        <p:cNvGrpSpPr/>
-        <p:nvPr/>
-      </p:nvGrpSpPr>
-      <p:grpSpPr/>
-      <p:sp>
-        <p:nvSpPr>
-          <p:cNvPr id="2" name="Title 1"/>
-          <p:cNvSpPr>
-            <a:spLocks noGrp="1"/>
-          </p:cNvSpPr>
-          <p:nvPr>
-            <p:ph type="title"/>
-          </p:nvPr>
-        </p:nvSpPr>
-        <p:spPr/>
-        <p:txBody>
-          <a:bodyPr/>
-          <a:lstStyle/>
-          <a:p>
-            <a:r>
+              <a:rPr dirty="0"/>
               <a:t>Sample demographics (n = 182)</a:t>
             </a:r>
           </a:p>
@@ -9380,8 +9324,8 @@
 </p:sld>
 </file>
 
-<file path=ppt/slides/slide42.xml><?xml version="1.0" encoding="utf-8"?>
-<p:sld xmlns:a="http://schemas.openxmlformats.org/drawingml/2006/main" xmlns:p="http://schemas.openxmlformats.org/presentationml/2006/main" xmlns:r="http://schemas.openxmlformats.org/officeDocument/2006/relationships">
+<file path=ppt/slides/slide41.xml><?xml version="1.0" encoding="utf-8"?>
+<p:sld xmlns:a="http://schemas.openxmlformats.org/drawingml/2006/main" xmlns:r="http://schemas.openxmlformats.org/officeDocument/2006/relationships" xmlns:p="http://schemas.openxmlformats.org/presentationml/2006/main">
   <p:cSld>
     <p:spTree>
       <p:nvGrpSpPr>
@@ -9389,7 +9333,14 @@
         <p:cNvGrpSpPr/>
         <p:nvPr/>
       </p:nvGrpSpPr>
-      <p:grpSpPr/>
+      <p:grpSpPr>
+        <a:xfrm>
+          <a:off x="0" y="0"/>
+          <a:ext cx="0" cy="0"/>
+          <a:chOff x="0" y="0"/>
+          <a:chExt cx="0" cy="0"/>
+        </a:xfrm>
+      </p:grpSpPr>
       <p:sp>
         <p:nvSpPr>
           <p:cNvPr id="2" name="Title 1"/>
@@ -9472,8 +9423,8 @@
 </p:sld>
 </file>
 
-<file path=ppt/slides/slide43.xml><?xml version="1.0" encoding="utf-8"?>
-<p:sld xmlns:a="http://schemas.openxmlformats.org/drawingml/2006/main" xmlns:p="http://schemas.openxmlformats.org/presentationml/2006/main" xmlns:r="http://schemas.openxmlformats.org/officeDocument/2006/relationships">
+<file path=ppt/slides/slide42.xml><?xml version="1.0" encoding="utf-8"?>
+<p:sld xmlns:a="http://schemas.openxmlformats.org/drawingml/2006/main" xmlns:r="http://schemas.openxmlformats.org/officeDocument/2006/relationships" xmlns:p="http://schemas.openxmlformats.org/presentationml/2006/main">
   <p:cSld>
     <p:spTree>
       <p:nvGrpSpPr>
@@ -9481,7 +9432,14 @@
         <p:cNvGrpSpPr/>
         <p:nvPr/>
       </p:nvGrpSpPr>
-      <p:grpSpPr/>
+      <p:grpSpPr>
+        <a:xfrm>
+          <a:off x="0" y="0"/>
+          <a:ext cx="0" cy="0"/>
+          <a:chOff x="0" y="0"/>
+          <a:chExt cx="0" cy="0"/>
+        </a:xfrm>
+      </p:grpSpPr>
       <p:sp>
         <p:nvSpPr>
           <p:cNvPr id="2" name="Title 1"/>
@@ -9535,8 +9493,8 @@
 </p:sld>
 </file>
 
-<file path=ppt/slides/slide44.xml><?xml version="1.0" encoding="utf-8"?>
-<p:sld xmlns:a="http://schemas.openxmlformats.org/drawingml/2006/main" xmlns:p="http://schemas.openxmlformats.org/presentationml/2006/main" xmlns:r="http://schemas.openxmlformats.org/officeDocument/2006/relationships">
+<file path=ppt/slides/slide43.xml><?xml version="1.0" encoding="utf-8"?>
+<p:sld xmlns:a="http://schemas.openxmlformats.org/drawingml/2006/main" xmlns:r="http://schemas.openxmlformats.org/officeDocument/2006/relationships" xmlns:p="http://schemas.openxmlformats.org/presentationml/2006/main">
   <p:cSld>
     <p:spTree>
       <p:nvGrpSpPr>
@@ -9544,7 +9502,14 @@
         <p:cNvGrpSpPr/>
         <p:nvPr/>
       </p:nvGrpSpPr>
-      <p:grpSpPr/>
+      <p:grpSpPr>
+        <a:xfrm>
+          <a:off x="0" y="0"/>
+          <a:ext cx="0" cy="0"/>
+          <a:chOff x="0" y="0"/>
+          <a:chExt cx="0" cy="0"/>
+        </a:xfrm>
+      </p:grpSpPr>
       <p:sp>
         <p:nvSpPr>
           <p:cNvPr id="2" name="Title 1"/>
@@ -9627,8 +9592,8 @@
 </p:sld>
 </file>
 
-<file path=ppt/slides/slide45.xml><?xml version="1.0" encoding="utf-8"?>
-<p:sld xmlns:a="http://schemas.openxmlformats.org/drawingml/2006/main" xmlns:p="http://schemas.openxmlformats.org/presentationml/2006/main" xmlns:r="http://schemas.openxmlformats.org/officeDocument/2006/relationships">
+<file path=ppt/slides/slide44.xml><?xml version="1.0" encoding="utf-8"?>
+<p:sld xmlns:a="http://schemas.openxmlformats.org/drawingml/2006/main" xmlns:r="http://schemas.openxmlformats.org/officeDocument/2006/relationships" xmlns:p="http://schemas.openxmlformats.org/presentationml/2006/main">
   <p:cSld>
     <p:spTree>
       <p:nvGrpSpPr>
@@ -9636,7 +9601,14 @@
         <p:cNvGrpSpPr/>
         <p:nvPr/>
       </p:nvGrpSpPr>
-      <p:grpSpPr/>
+      <p:grpSpPr>
+        <a:xfrm>
+          <a:off x="0" y="0"/>
+          <a:ext cx="0" cy="0"/>
+          <a:chOff x="0" y="0"/>
+          <a:chExt cx="0" cy="0"/>
+        </a:xfrm>
+      </p:grpSpPr>
       <p:sp>
         <p:nvSpPr>
           <p:cNvPr id="2" name="Title 1"/>
@@ -9705,7 +9677,7 @@
           <a:lstStyle/>
           <a:p>
             <a:r>
-              <a:rPr sz="1400" i="1"/>
+              <a:rPr sz="1400" i="1" dirty="0"/>
               <a:t>Force shows the cleanest dose-response of the 5 survey-derived factors</a:t>
             </a:r>
           </a:p>
@@ -9719,8 +9691,8 @@
 </p:sld>
 </file>
 
-<file path=ppt/slides/slide46.xml><?xml version="1.0" encoding="utf-8"?>
-<p:sld xmlns:a="http://schemas.openxmlformats.org/drawingml/2006/main" xmlns:p="http://schemas.openxmlformats.org/presentationml/2006/main" xmlns:r="http://schemas.openxmlformats.org/officeDocument/2006/relationships">
+<file path=ppt/slides/slide45.xml><?xml version="1.0" encoding="utf-8"?>
+<p:sld xmlns:a="http://schemas.openxmlformats.org/drawingml/2006/main" xmlns:r="http://schemas.openxmlformats.org/officeDocument/2006/relationships" xmlns:p="http://schemas.openxmlformats.org/presentationml/2006/main">
   <p:cSld>
     <p:spTree>
       <p:nvGrpSpPr>
@@ -9728,7 +9700,14 @@
         <p:cNvGrpSpPr/>
         <p:nvPr/>
       </p:nvGrpSpPr>
-      <p:grpSpPr/>
+      <p:grpSpPr>
+        <a:xfrm>
+          <a:off x="0" y="0"/>
+          <a:ext cx="0" cy="0"/>
+          <a:chOff x="0" y="0"/>
+          <a:chExt cx="0" cy="0"/>
+        </a:xfrm>
+      </p:grpSpPr>
       <p:sp>
         <p:nvSpPr>
           <p:cNvPr id="2" name="Title 1"/>
@@ -9811,8 +9790,8 @@
 </p:sld>
 </file>
 
-<file path=ppt/slides/slide47.xml><?xml version="1.0" encoding="utf-8"?>
-<p:sld xmlns:a="http://schemas.openxmlformats.org/drawingml/2006/main" xmlns:p="http://schemas.openxmlformats.org/presentationml/2006/main" xmlns:r="http://schemas.openxmlformats.org/officeDocument/2006/relationships">
+<file path=ppt/slides/slide46.xml><?xml version="1.0" encoding="utf-8"?>
+<p:sld xmlns:a="http://schemas.openxmlformats.org/drawingml/2006/main" xmlns:r="http://schemas.openxmlformats.org/officeDocument/2006/relationships" xmlns:p="http://schemas.openxmlformats.org/presentationml/2006/main">
   <p:cSld>
     <p:spTree>
       <p:nvGrpSpPr>
@@ -9820,7 +9799,14 @@
         <p:cNvGrpSpPr/>
         <p:nvPr/>
       </p:nvGrpSpPr>
-      <p:grpSpPr/>
+      <p:grpSpPr>
+        <a:xfrm>
+          <a:off x="0" y="0"/>
+          <a:ext cx="0" cy="0"/>
+          <a:chOff x="0" y="0"/>
+          <a:chExt cx="0" cy="0"/>
+        </a:xfrm>
+      </p:grpSpPr>
       <p:sp>
         <p:nvSpPr>
           <p:cNvPr id="2" name="Title 1"/>
@@ -9865,61 +9851,79 @@
           <a:lstStyle/>
           <a:p>
             <a:r>
-              <a:rPr sz="1800"/>
-              <a:t>Best model per risk factor (5-fold CV, after GridSearchCV + SMOTE):</a:t>
-            </a:r>
-          </a:p>
-          <a:p>
-            <a:r>
-              <a:rPr sz="1800"/>
-              <a:t/>
-            </a:r>
-          </a:p>
-          <a:p>
-            <a:r>
-              <a:rPr sz="1800"/>
+              <a:rPr sz="1800" dirty="0"/>
+              <a:t>Best model per risk factor (5-fold CV, after </a:t>
+            </a:r>
+            <a:r>
+              <a:rPr sz="1800" dirty="0" err="1"/>
+              <a:t>GridSearchCV</a:t>
+            </a:r>
+            <a:r>
+              <a:rPr sz="1800" dirty="0"/>
+              <a:t> + SMOTE):</a:t>
+            </a:r>
+          </a:p>
+          <a:p>
+            <a:endParaRPr sz="1800" dirty="0"/>
+          </a:p>
+          <a:p>
+            <a:r>
+              <a:rPr sz="1800" dirty="0"/>
               <a:t>Force           Random Forest               59%   AUC 74%</a:t>
             </a:r>
           </a:p>
           <a:p>
             <a:r>
-              <a:rPr sz="1800"/>
-              <a:t>Repetition      XGBoost                     74%   AUC 83%</a:t>
-            </a:r>
-          </a:p>
-          <a:p>
-            <a:r>
-              <a:rPr sz="1800"/>
+              <a:rPr sz="1800" dirty="0"/>
+              <a:t>Repetition      </a:t>
+            </a:r>
+            <a:r>
+              <a:rPr sz="1800" dirty="0" err="1"/>
+              <a:t>XGBoost</a:t>
+            </a:r>
+            <a:r>
+              <a:rPr sz="1800" dirty="0"/>
+              <a:t>                     74%   AUC 83%</a:t>
+            </a:r>
+          </a:p>
+          <a:p>
+            <a:r>
+              <a:rPr sz="1800" dirty="0"/>
               <a:t>Duration        Extra Trees                 64%   AUC 77%</a:t>
             </a:r>
           </a:p>
           <a:p>
             <a:r>
-              <a:rPr sz="1800"/>
+              <a:rPr sz="1800" dirty="0"/>
               <a:t>Vibration       Logistic Regression         53%   AUC 70%</a:t>
             </a:r>
           </a:p>
           <a:p>
             <a:r>
-              <a:rPr sz="1800"/>
+              <a:rPr sz="1800" dirty="0"/>
               <a:t>Contact Stress  Stacking Ensemble           61%   AUC 77%</a:t>
             </a:r>
           </a:p>
           <a:p>
             <a:r>
-              <a:rPr sz="1800"/>
-              <a:t>Posture         HistGradientBoosting        89%   AUC 89%</a:t>
-            </a:r>
-          </a:p>
-          <a:p>
-            <a:r>
-              <a:rPr sz="1800"/>
-              <a:t/>
-            </a:r>
-          </a:p>
-          <a:p>
-            <a:r>
-              <a:rPr sz="1800"/>
+              <a:rPr sz="1800" dirty="0"/>
+              <a:t>Posture         </a:t>
+            </a:r>
+            <a:r>
+              <a:rPr sz="1800" dirty="0" err="1"/>
+              <a:t>HistGradientBoosting</a:t>
+            </a:r>
+            <a:r>
+              <a:rPr sz="1800" dirty="0"/>
+              <a:t>        89%   AUC 89%</a:t>
+            </a:r>
+          </a:p>
+          <a:p>
+            <a:endParaRPr sz="1800" dirty="0"/>
+          </a:p>
+          <a:p>
+            <a:r>
+              <a:rPr sz="1800" dirty="0"/>
               <a:t>5 of 6 factors meet the 60% lower bound of the published survey-based MSD range.</a:t>
             </a:r>
           </a:p>
@@ -9933,8 +9937,8 @@
 </p:sld>
 </file>
 
-<file path=ppt/slides/slide48.xml><?xml version="1.0" encoding="utf-8"?>
-<p:sld xmlns:a="http://schemas.openxmlformats.org/drawingml/2006/main" xmlns:p="http://schemas.openxmlformats.org/presentationml/2006/main" xmlns:r="http://schemas.openxmlformats.org/officeDocument/2006/relationships">
+<file path=ppt/slides/slide47.xml><?xml version="1.0" encoding="utf-8"?>
+<p:sld xmlns:a="http://schemas.openxmlformats.org/drawingml/2006/main" xmlns:r="http://schemas.openxmlformats.org/officeDocument/2006/relationships" xmlns:p="http://schemas.openxmlformats.org/presentationml/2006/main">
   <p:cSld>
     <p:spTree>
       <p:nvGrpSpPr>
@@ -9942,7 +9946,14 @@
         <p:cNvGrpSpPr/>
         <p:nvPr/>
       </p:nvGrpSpPr>
-      <p:grpSpPr/>
+      <p:grpSpPr>
+        <a:xfrm>
+          <a:off x="0" y="0"/>
+          <a:ext cx="0" cy="0"/>
+          <a:chOff x="0" y="0"/>
+          <a:chExt cx="0" cy="0"/>
+        </a:xfrm>
+      </p:grpSpPr>
       <p:sp>
         <p:nvSpPr>
           <p:cNvPr id="2" name="Title 1"/>
@@ -9996,8 +10007,8 @@
 </p:sld>
 </file>
 
-<file path=ppt/slides/slide49.xml><?xml version="1.0" encoding="utf-8"?>
-<p:sld xmlns:a="http://schemas.openxmlformats.org/drawingml/2006/main" xmlns:p="http://schemas.openxmlformats.org/presentationml/2006/main" xmlns:r="http://schemas.openxmlformats.org/officeDocument/2006/relationships">
+<file path=ppt/slides/slide48.xml><?xml version="1.0" encoding="utf-8"?>
+<p:sld xmlns:a="http://schemas.openxmlformats.org/drawingml/2006/main" xmlns:r="http://schemas.openxmlformats.org/officeDocument/2006/relationships" xmlns:p="http://schemas.openxmlformats.org/presentationml/2006/main">
   <p:cSld>
     <p:spTree>
       <p:nvGrpSpPr>
@@ -10005,7 +10016,14 @@
         <p:cNvGrpSpPr/>
         <p:nvPr/>
       </p:nvGrpSpPr>
-      <p:grpSpPr/>
+      <p:grpSpPr>
+        <a:xfrm>
+          <a:off x="0" y="0"/>
+          <a:ext cx="0" cy="0"/>
+          <a:chOff x="0" y="0"/>
+          <a:chExt cx="0" cy="0"/>
+        </a:xfrm>
+      </p:grpSpPr>
       <p:sp>
         <p:nvSpPr>
           <p:cNvPr id="2" name="Title 1"/>
@@ -10076,6 +10094,105 @@
             <a:r>
               <a:rPr sz="1400" i="1"/>
               <a:t>AUC &gt; 0.70 for 5 of 6 factors</a:t>
+            </a:r>
+          </a:p>
+        </p:txBody>
+      </p:sp>
+    </p:spTree>
+  </p:cSld>
+  <p:clrMapOvr>
+    <a:masterClrMapping/>
+  </p:clrMapOvr>
+</p:sld>
+</file>
+
+<file path=ppt/slides/slide49.xml><?xml version="1.0" encoding="utf-8"?>
+<p:sld xmlns:a="http://schemas.openxmlformats.org/drawingml/2006/main" xmlns:r="http://schemas.openxmlformats.org/officeDocument/2006/relationships" xmlns:p="http://schemas.openxmlformats.org/presentationml/2006/main">
+  <p:cSld>
+    <p:spTree>
+      <p:nvGrpSpPr>
+        <p:cNvPr id="1" name=""/>
+        <p:cNvGrpSpPr/>
+        <p:nvPr/>
+      </p:nvGrpSpPr>
+      <p:grpSpPr>
+        <a:xfrm>
+          <a:off x="0" y="0"/>
+          <a:ext cx="0" cy="0"/>
+          <a:chOff x="0" y="0"/>
+          <a:chExt cx="0" cy="0"/>
+        </a:xfrm>
+      </p:grpSpPr>
+      <p:sp>
+        <p:nvSpPr>
+          <p:cNvPr id="2" name="Title 1"/>
+          <p:cNvSpPr>
+            <a:spLocks noGrp="1"/>
+          </p:cNvSpPr>
+          <p:nvPr>
+            <p:ph type="title"/>
+          </p:nvPr>
+        </p:nvSpPr>
+        <p:spPr/>
+        <p:txBody>
+          <a:bodyPr/>
+          <a:lstStyle/>
+          <a:p>
+            <a:r>
+              <a:t>Top features per model</a:t>
+            </a:r>
+          </a:p>
+        </p:txBody>
+      </p:sp>
+      <p:pic>
+        <p:nvPicPr>
+          <p:cNvPr id="3" name="Picture 2" descr="feature_importance.png"/>
+          <p:cNvPicPr>
+            <a:picLocks noChangeAspect="1"/>
+          </p:cNvPicPr>
+          <p:nvPr/>
+        </p:nvPicPr>
+        <p:blipFill>
+          <a:blip r:embed="rId2"/>
+          <a:stretch>
+            <a:fillRect/>
+          </a:stretch>
+        </p:blipFill>
+        <p:spPr>
+          <a:xfrm>
+            <a:off x="2712568" y="1371600"/>
+            <a:ext cx="6766863" cy="4572000"/>
+          </a:xfrm>
+          <a:prstGeom prst="rect">
+            <a:avLst/>
+          </a:prstGeom>
+        </p:spPr>
+      </p:pic>
+      <p:sp>
+        <p:nvSpPr>
+          <p:cNvPr id="4" name="TextBox 3"/>
+          <p:cNvSpPr txBox="1"/>
+          <p:nvPr/>
+        </p:nvSpPr>
+        <p:spPr>
+          <a:xfrm>
+            <a:off x="457200" y="6126480"/>
+            <a:ext cx="11277600" cy="640080"/>
+          </a:xfrm>
+          <a:prstGeom prst="rect">
+            <a:avLst/>
+          </a:prstGeom>
+          <a:noFill/>
+        </p:spPr>
+        <p:txBody>
+          <a:bodyPr wrap="none">
+            <a:spAutoFit/>
+          </a:bodyPr>
+          <a:lstStyle/>
+          <a:p>
+            <a:r>
+              <a:rPr sz="1400" i="1"/>
+              <a:t>workload_score, fatigue_score, and age_ord recur across factors</a:t>
             </a:r>
           </a:p>
         </p:txBody>
@@ -10517,7 +10634,7 @@
 </file>
 
 <file path=ppt/slides/slide50.xml><?xml version="1.0" encoding="utf-8"?>
-<p:sld xmlns:a="http://schemas.openxmlformats.org/drawingml/2006/main" xmlns:p="http://schemas.openxmlformats.org/presentationml/2006/main" xmlns:r="http://schemas.openxmlformats.org/officeDocument/2006/relationships">
+<p:sld xmlns:a="http://schemas.openxmlformats.org/drawingml/2006/main" xmlns:r="http://schemas.openxmlformats.org/officeDocument/2006/relationships" xmlns:p="http://schemas.openxmlformats.org/presentationml/2006/main">
   <p:cSld>
     <p:spTree>
       <p:nvGrpSpPr>
@@ -10525,7 +10642,14 @@
         <p:cNvGrpSpPr/>
         <p:nvPr/>
       </p:nvGrpSpPr>
-      <p:grpSpPr/>
+      <p:grpSpPr>
+        <a:xfrm>
+          <a:off x="0" y="0"/>
+          <a:ext cx="0" cy="0"/>
+          <a:chOff x="0" y="0"/>
+          <a:chExt cx="0" cy="0"/>
+        </a:xfrm>
+      </p:grpSpPr>
       <p:sp>
         <p:nvSpPr>
           <p:cNvPr id="2" name="Title 1"/>
@@ -10542,45 +10666,21 @@
           <a:lstStyle/>
           <a:p>
             <a:r>
-              <a:t>Top features per model</a:t>
-            </a:r>
-          </a:p>
-        </p:txBody>
-      </p:sp>
-      <p:pic>
-        <p:nvPicPr>
-          <p:cNvPr id="3" name="Picture 2" descr="feature_importance.png"/>
-          <p:cNvPicPr>
-            <a:picLocks noChangeAspect="1"/>
-          </p:cNvPicPr>
+              <a:t>Comparison with published benchmarks</a:t>
+            </a:r>
+          </a:p>
+        </p:txBody>
+      </p:sp>
+      <p:sp>
+        <p:nvSpPr>
+          <p:cNvPr id="3" name="TextBox 2"/>
+          <p:cNvSpPr txBox="1"/>
           <p:nvPr/>
-        </p:nvPicPr>
-        <p:blipFill>
-          <a:blip r:embed="rId2"/>
-          <a:stretch>
-            <a:fillRect/>
-          </a:stretch>
-        </p:blipFill>
+        </p:nvSpPr>
         <p:spPr>
           <a:xfrm>
-            <a:off x="2712568" y="1371600"/>
-            <a:ext cx="6766863" cy="4572000"/>
-          </a:xfrm>
-          <a:prstGeom prst="rect">
-            <a:avLst/>
-          </a:prstGeom>
-        </p:spPr>
-      </p:pic>
-      <p:sp>
-        <p:nvSpPr>
-          <p:cNvPr id="4" name="TextBox 3"/>
-          <p:cNvSpPr txBox="1"/>
-          <p:nvPr/>
-        </p:nvSpPr>
-        <p:spPr>
-          <a:xfrm>
-            <a:off x="457200" y="6126480"/>
-            <a:ext cx="11277600" cy="640080"/>
+            <a:off x="548640" y="1280160"/>
+            <a:ext cx="11094720" cy="2031325"/>
           </a:xfrm>
           <a:prstGeom prst="rect">
             <a:avLst/>
@@ -10588,14 +10688,44 @@
           <a:noFill/>
         </p:spPr>
         <p:txBody>
-          <a:bodyPr wrap="none">
+          <a:bodyPr wrap="square">
             <a:spAutoFit/>
           </a:bodyPr>
           <a:lstStyle/>
           <a:p>
             <a:r>
-              <a:rPr sz="1400" i="1"/>
-              <a:t>workload_score, fatigue_score, and age_ord recur across factors</a:t>
+              <a:rPr sz="1800" dirty="0"/>
+              <a:t>Survey-based MSD-prediction studies typically reach 60-80% accuracy</a:t>
+            </a:r>
+          </a:p>
+          <a:p>
+            <a:endParaRPr sz="1800" dirty="0"/>
+          </a:p>
+          <a:p>
+            <a:r>
+              <a:rPr sz="1800" dirty="0"/>
+              <a:t>Sensor-based studies (IMU / EMG / computer vision) reach 90-99% but require</a:t>
+            </a:r>
+          </a:p>
+          <a:p>
+            <a:r>
+              <a:rPr sz="1800" dirty="0"/>
+              <a:t>equipment we did not use.</a:t>
+            </a:r>
+          </a:p>
+          <a:p>
+            <a:endParaRPr sz="1800" dirty="0"/>
+          </a:p>
+          <a:p>
+            <a:r>
+              <a:rPr sz="1800" dirty="0"/>
+              <a:t>Our 5/6 factors at 60%+ from survey data alone is competitive with the published</a:t>
+            </a:r>
+          </a:p>
+          <a:p>
+            <a:r>
+              <a:rPr sz="1800" dirty="0"/>
+              <a:t>survey-based range; Vibration at 53% sits below the band for documented reasons.</a:t>
             </a:r>
           </a:p>
         </p:txBody>
@@ -10609,7 +10739,7 @@
 </file>
 
 <file path=ppt/slides/slide51.xml><?xml version="1.0" encoding="utf-8"?>
-<p:sld xmlns:a="http://schemas.openxmlformats.org/drawingml/2006/main" xmlns:p="http://schemas.openxmlformats.org/presentationml/2006/main" xmlns:r="http://schemas.openxmlformats.org/officeDocument/2006/relationships">
+<p:sld xmlns:a="http://schemas.openxmlformats.org/drawingml/2006/main" xmlns:r="http://schemas.openxmlformats.org/officeDocument/2006/relationships" xmlns:p="http://schemas.openxmlformats.org/presentationml/2006/main">
   <p:cSld>
     <p:spTree>
       <p:nvGrpSpPr>
@@ -10617,7 +10747,14 @@
         <p:cNvGrpSpPr/>
         <p:nvPr/>
       </p:nvGrpSpPr>
-      <p:grpSpPr/>
+      <p:grpSpPr>
+        <a:xfrm>
+          <a:off x="0" y="0"/>
+          <a:ext cx="0" cy="0"/>
+          <a:chOff x="0" y="0"/>
+          <a:chExt cx="0" cy="0"/>
+        </a:xfrm>
+      </p:grpSpPr>
       <p:sp>
         <p:nvSpPr>
           <p:cNvPr id="2" name="Title 1"/>
@@ -10634,7 +10771,7 @@
           <a:lstStyle/>
           <a:p>
             <a:r>
-              <a:t>Comparison with published benchmarks</a:t>
+              <a:t>Limitations</a:t>
             </a:r>
           </a:p>
         </p:txBody>
@@ -10663,49 +10800,58 @@
           <a:p>
             <a:r>
               <a:rPr sz="1800"/>
-              <a:t>Survey-based MSD-prediction studies typically reach 60-80% accuracy</a:t>
-            </a:r>
+              <a:t>1. n = 182 self-report sample. Cross-sectional, single-region (Tamil Nadu).</a:t>
+            </a:r>
+          </a:p>
+          <a:p>
+            <a:endParaRPr sz="1800"/>
           </a:p>
           <a:p>
             <a:r>
               <a:rPr sz="1800"/>
-              <a:t>(Annals of Occupational and Environmental Medicine, 2024 - review of 130 studies).</a:t>
-            </a:r>
+              <a:t>2. Posture per-rider linkage is approximate. The RULA + QEC observations shared</a:t>
+            </a:r>
+          </a:p>
+          <a:p>
+            <a:r>
+              <a:rPr sz="1600"/>
+              <a:t>   no rider identifier with the survey; a severity-rank merge was used.</a:t>
+            </a:r>
+          </a:p>
+          <a:p>
+            <a:r>
+              <a:rPr sz="1600"/>
+              <a:t>   This inflates the chi-square between Posture and discomfort and the ML</a:t>
+            </a:r>
+          </a:p>
+          <a:p>
+            <a:r>
+              <a:rPr sz="1600"/>
+              <a:t>   accuracy on Posture (89%).</a:t>
+            </a:r>
+          </a:p>
+          <a:p>
+            <a:endParaRPr sz="1600"/>
           </a:p>
           <a:p>
             <a:r>
               <a:rPr sz="1800"/>
-              <a:t/>
-            </a:r>
+              <a:t>3. Vibration's 53% accuracy reflects a real signal ceiling once vehicle_rank,</a:t>
+            </a:r>
+          </a:p>
+          <a:p>
+            <a:r>
+              <a:rPr sz="1600"/>
+              <a:t>   work_hours_num, and vibration_index are all excluded to prevent leakage.</a:t>
+            </a:r>
+          </a:p>
+          <a:p>
+            <a:endParaRPr sz="1600"/>
           </a:p>
           <a:p>
             <a:r>
               <a:rPr sz="1800"/>
-              <a:t>Sensor-based studies (IMU / EMG / computer vision) reach 90-99% but require</a:t>
-            </a:r>
-          </a:p>
-          <a:p>
-            <a:r>
-              <a:rPr sz="1800"/>
-              <a:t>equipment we did not use.</a:t>
-            </a:r>
-          </a:p>
-          <a:p>
-            <a:r>
-              <a:rPr sz="1800"/>
-              <a:t/>
-            </a:r>
-          </a:p>
-          <a:p>
-            <a:r>
-              <a:rPr sz="1800"/>
-              <a:t>Our 5/6 factors at 60%+ from survey data alone is competitive with the published</a:t>
-            </a:r>
-          </a:p>
-          <a:p>
-            <a:r>
-              <a:rPr sz="1800"/>
-              <a:t>survey-based range; Vibration at 53% sits below the band for documented reasons.</a:t>
+              <a:t>4. Self-report biases apply to discomfort, fatigue, and workload measures.</a:t>
             </a:r>
           </a:p>
         </p:txBody>
@@ -10719,7 +10865,7 @@
 </file>
 
 <file path=ppt/slides/slide52.xml><?xml version="1.0" encoding="utf-8"?>
-<p:sld xmlns:a="http://schemas.openxmlformats.org/drawingml/2006/main" xmlns:p="http://schemas.openxmlformats.org/presentationml/2006/main" xmlns:r="http://schemas.openxmlformats.org/officeDocument/2006/relationships">
+<p:sld xmlns:a="http://schemas.openxmlformats.org/drawingml/2006/main" xmlns:r="http://schemas.openxmlformats.org/officeDocument/2006/relationships" xmlns:p="http://schemas.openxmlformats.org/presentationml/2006/main">
   <p:cSld>
     <p:spTree>
       <p:nvGrpSpPr>
@@ -10727,7 +10873,14 @@
         <p:cNvGrpSpPr/>
         <p:nvPr/>
       </p:nvGrpSpPr>
-      <p:grpSpPr/>
+      <p:grpSpPr>
+        <a:xfrm>
+          <a:off x="0" y="0"/>
+          <a:ext cx="0" cy="0"/>
+          <a:chOff x="0" y="0"/>
+          <a:chExt cx="0" cy="0"/>
+        </a:xfrm>
+      </p:grpSpPr>
       <p:sp>
         <p:nvSpPr>
           <p:cNvPr id="2" name="Title 1"/>
@@ -10744,7 +10897,7 @@
           <a:lstStyle/>
           <a:p>
             <a:r>
-              <a:t>Limitations</a:t>
+              <a:t>Recommendations for rider safety</a:t>
             </a:r>
           </a:p>
         </p:txBody>
@@ -10773,67 +10926,58 @@
           <a:p>
             <a:r>
               <a:rPr sz="1800"/>
-              <a:t>1. n = 182 self-report sample. Cross-sectional, single-region (Tamil Nadu).</a:t>
-            </a:r>
+              <a:t>Duration (49% of riders in High band - largest population burden):</a:t>
+            </a:r>
+          </a:p>
+          <a:p>
+            <a:r>
+              <a:rPr sz="1600"/>
+              <a:t>   shift-length caps and mandatory breaks every 2 hours</a:t>
+            </a:r>
+          </a:p>
+          <a:p>
+            <a:endParaRPr sz="1600"/>
           </a:p>
           <a:p>
             <a:r>
               <a:rPr sz="1800"/>
-              <a:t/>
-            </a:r>
+              <a:t>Force (only factor significantly associated with discomfort, p = 0.035):</a:t>
+            </a:r>
+          </a:p>
+          <a:p>
+            <a:r>
+              <a:rPr sz="1600"/>
+              <a:t>   limit carried-package weight; train safer lifting technique</a:t>
+            </a:r>
+          </a:p>
+          <a:p>
+            <a:endParaRPr sz="1600"/>
           </a:p>
           <a:p>
             <a:r>
               <a:rPr sz="1800"/>
-              <a:t>2. Posture per-rider linkage is approximate. The RULA + QEC observations shared</a:t>
+              <a:t>Contact Stress (handheld carriers reported less discomfort):</a:t>
             </a:r>
           </a:p>
           <a:p>
             <a:r>
               <a:rPr sz="1600"/>
-              <a:t>   no rider identifier with the survey; a severity-rank merge was used.</a:t>
+              <a:t>   encourage bike-storage box or backpack over handheld delivery</a:t>
+            </a:r>
+          </a:p>
+          <a:p>
+            <a:endParaRPr sz="1600"/>
+          </a:p>
+          <a:p>
+            <a:r>
+              <a:rPr sz="1800"/>
+              <a:t>Age and job duration (strongest individual-level discomfort predictors):</a:t>
             </a:r>
           </a:p>
           <a:p>
             <a:r>
               <a:rPr sz="1600"/>
-              <a:t>   This inflates the chi-square between Posture and discomfort and the ML</a:t>
-            </a:r>
-          </a:p>
-          <a:p>
-            <a:r>
-              <a:rPr sz="1600"/>
-              <a:t>   accuracy on Posture (89%).</a:t>
-            </a:r>
-          </a:p>
-          <a:p>
-            <a:r>
-              <a:rPr sz="1800"/>
-              <a:t/>
-            </a:r>
-          </a:p>
-          <a:p>
-            <a:r>
-              <a:rPr sz="1800"/>
-              <a:t>3. Vibration's 53% accuracy reflects a real signal ceiling once vehicle_rank,</a:t>
-            </a:r>
-          </a:p>
-          <a:p>
-            <a:r>
-              <a:rPr sz="1600"/>
-              <a:t>   work_hours_num, and vibration_index are all excluded to prevent leakage.</a:t>
-            </a:r>
-          </a:p>
-          <a:p>
-            <a:r>
-              <a:rPr sz="1800"/>
-              <a:t/>
-            </a:r>
-          </a:p>
-          <a:p>
-            <a:r>
-              <a:rPr sz="1800"/>
-              <a:t>4. Self-report biases apply to discomfort, fatigue, and workload measures.</a:t>
+              <a:t>   workload tapering for riders over 12 months tenure or over 35 years old</a:t>
             </a:r>
           </a:p>
         </p:txBody>
@@ -10847,126 +10991,69 @@
 </file>
 
 <file path=ppt/slides/slide53.xml><?xml version="1.0" encoding="utf-8"?>
-<p:sld xmlns:a="http://schemas.openxmlformats.org/drawingml/2006/main" xmlns:p="http://schemas.openxmlformats.org/presentationml/2006/main" xmlns:r="http://schemas.openxmlformats.org/officeDocument/2006/relationships">
+<p:sld xmlns:a="http://schemas.openxmlformats.org/drawingml/2006/main" xmlns:r="http://schemas.openxmlformats.org/officeDocument/2006/relationships" xmlns:p="http://schemas.openxmlformats.org/presentationml/2006/main">
   <p:cSld>
     <p:spTree>
       <p:nvGrpSpPr>
-        <p:cNvPr id="1" name=""/>
+        <p:cNvPr id="1" name="">
+          <a:extLst>
+            <a:ext uri="{FF2B5EF4-FFF2-40B4-BE49-F238E27FC236}">
+              <a16:creationId xmlns:a16="http://schemas.microsoft.com/office/drawing/2014/main" id="{D37942D0-0D70-589E-4C8C-483BF92661B5}"/>
+            </a:ext>
+          </a:extLst>
+        </p:cNvPr>
         <p:cNvGrpSpPr/>
         <p:nvPr/>
       </p:nvGrpSpPr>
-      <p:grpSpPr/>
-      <p:sp>
-        <p:nvSpPr>
-          <p:cNvPr id="2" name="Title 1"/>
+      <p:grpSpPr>
+        <a:xfrm>
+          <a:off x="0" y="0"/>
+          <a:ext cx="0" cy="0"/>
+          <a:chOff x="0" y="0"/>
+          <a:chExt cx="0" cy="0"/>
+        </a:xfrm>
+      </p:grpSpPr>
+      <p:sp>
+        <p:nvSpPr>
+          <p:cNvPr id="2" name="Title 1">
+            <a:extLst>
+              <a:ext uri="{FF2B5EF4-FFF2-40B4-BE49-F238E27FC236}">
+                <a16:creationId xmlns:a16="http://schemas.microsoft.com/office/drawing/2014/main" id="{9C745776-0702-1FE3-1C3F-291E63955224}"/>
+              </a:ext>
+            </a:extLst>
+          </p:cNvPr>
           <p:cNvSpPr>
             <a:spLocks noGrp="1"/>
           </p:cNvSpPr>
           <p:nvPr>
             <p:ph type="title"/>
           </p:nvPr>
-        </p:nvSpPr>
-        <p:spPr/>
-        <p:txBody>
-          <a:bodyPr/>
-          <a:lstStyle/>
-          <a:p>
-            <a:r>
-              <a:t>Recommendations for rider safety</a:t>
-            </a:r>
-          </a:p>
-        </p:txBody>
-      </p:sp>
-      <p:sp>
-        <p:nvSpPr>
-          <p:cNvPr id="3" name="TextBox 2"/>
-          <p:cNvSpPr txBox="1"/>
-          <p:nvPr/>
         </p:nvSpPr>
         <p:spPr>
           <a:xfrm>
-            <a:off x="548640" y="1280160"/>
-            <a:ext cx="11094720" cy="5029200"/>
+            <a:off x="4774063" y="2857500"/>
+            <a:ext cx="2643873" cy="1143000"/>
           </a:xfrm>
-          <a:prstGeom prst="rect">
-            <a:avLst/>
-          </a:prstGeom>
-          <a:noFill/>
         </p:spPr>
         <p:txBody>
-          <a:bodyPr wrap="square">
-            <a:spAutoFit/>
-          </a:bodyPr>
-          <a:lstStyle/>
-          <a:p>
-            <a:r>
-              <a:rPr sz="1800"/>
-              <a:t>Duration (49% of riders in High band - largest population burden):</a:t>
-            </a:r>
-          </a:p>
-          <a:p>
-            <a:r>
-              <a:rPr sz="1600"/>
-              <a:t>   shift-length caps and mandatory breaks every 2 hours</a:t>
-            </a:r>
-          </a:p>
-          <a:p>
-            <a:r>
-              <a:rPr sz="1800"/>
-              <a:t/>
-            </a:r>
-          </a:p>
-          <a:p>
-            <a:r>
-              <a:rPr sz="1800"/>
-              <a:t>Force (only factor significantly associated with discomfort, p = 0.035):</a:t>
-            </a:r>
-          </a:p>
-          <a:p>
-            <a:r>
-              <a:rPr sz="1600"/>
-              <a:t>   limit carried-package weight; train safer lifting technique</a:t>
-            </a:r>
-          </a:p>
-          <a:p>
-            <a:r>
-              <a:rPr sz="1800"/>
-              <a:t/>
-            </a:r>
-          </a:p>
-          <a:p>
-            <a:r>
-              <a:rPr sz="1800"/>
-              <a:t>Contact Stress (handheld carriers reported less discomfort):</a:t>
-            </a:r>
-          </a:p>
-          <a:p>
-            <a:r>
-              <a:rPr sz="1600"/>
-              <a:t>   encourage bike-storage box or backpack over handheld delivery</a:t>
-            </a:r>
-          </a:p>
-          <a:p>
-            <a:r>
-              <a:rPr sz="1800"/>
-              <a:t/>
-            </a:r>
-          </a:p>
-          <a:p>
-            <a:r>
-              <a:rPr sz="1800"/>
-              <a:t>Age and job duration (strongest individual-level discomfort predictors):</a:t>
-            </a:r>
-          </a:p>
-          <a:p>
-            <a:r>
-              <a:rPr sz="1600"/>
-              <a:t>   workload tapering for riders over 12 months tenure or over 35 years old</a:t>
-            </a:r>
+          <a:bodyPr/>
+          <a:lstStyle/>
+          <a:p>
+            <a:pPr algn="ctr"/>
+            <a:r>
+              <a:rPr lang="en-US" dirty="0"/>
+              <a:t>Thank You</a:t>
+            </a:r>
+            <a:endParaRPr dirty="0"/>
           </a:p>
         </p:txBody>
       </p:sp>
     </p:spTree>
+    <p:extLst>
+      <p:ext uri="{BB962C8B-B14F-4D97-AF65-F5344CB8AC3E}">
+        <p14:creationId xmlns:p14="http://schemas.microsoft.com/office/powerpoint/2010/main" val="2503925356"/>
+      </p:ext>
+    </p:extLst>
   </p:cSld>
   <p:clrMapOvr>
     <a:masterClrMapping/>

</xml_diff>

<commit_message>
Rebuild WITH_RESULTS deck (53 slides) with refreshed Phase 4-7 figures and tables
</commit_message>
<xml_diff>
--- a/deck/Ergonomic_Risk_Factor_Prediction_Project_Plan_WITH_RESULTS.pptx
+++ b/deck/Ergonomic_Risk_Factor_Prediction_Project_Plan_WITH_RESULTS.pptx
@@ -43,21 +43,21 @@
     <p:sldId id="302" r:id="rId37"/>
     <p:sldId id="295" r:id="rId38"/>
     <p:sldId id="275" r:id="rId39"/>
-    <p:sldId id="303" r:id="rId40"/>
-    <p:sldId id="304" r:id="rId41"/>
-    <p:sldId id="305" r:id="rId42"/>
-    <p:sldId id="306" r:id="rId43"/>
-    <p:sldId id="307" r:id="rId44"/>
-    <p:sldId id="308" r:id="rId45"/>
-    <p:sldId id="309" r:id="rId46"/>
-    <p:sldId id="310" r:id="rId47"/>
-    <p:sldId id="311" r:id="rId48"/>
-    <p:sldId id="312" r:id="rId49"/>
-    <p:sldId id="313" r:id="rId50"/>
-    <p:sldId id="314" r:id="rId51"/>
-    <p:sldId id="315" r:id="rId52"/>
-    <p:sldId id="316" r:id="rId53"/>
-    <p:sldId id="301" r:id="rId54"/>
+    <p:sldId id="303" r:id="rId45"/>
+    <p:sldId id="304" r:id="rId46"/>
+    <p:sldId id="305" r:id="rId47"/>
+    <p:sldId id="306" r:id="rId48"/>
+    <p:sldId id="307" r:id="rId49"/>
+    <p:sldId id="308" r:id="rId50"/>
+    <p:sldId id="309" r:id="rId51"/>
+    <p:sldId id="310" r:id="rId52"/>
+    <p:sldId id="311" r:id="rId53"/>
+    <p:sldId id="312" r:id="rId54"/>
+    <p:sldId id="313" r:id="rId55"/>
+    <p:sldId id="314" r:id="rId56"/>
+    <p:sldId id="315" r:id="rId57"/>
+    <p:sldId id="316" r:id="rId58"/>
+    <p:sldId id="301" r:id="rId40"/>
   </p:sldIdLst>
   <p:sldSz cx="12192000" cy="6858000"/>
   <p:notesSz cx="6858000" cy="9144000"/>
@@ -354,7 +354,7 @@
           <a:p>
             <a:fld id="{5BCAD085-E8A6-8845-BD4E-CB4CCA059FC4}" type="datetimeFigureOut">
               <a:rPr lang="en-US" smtClean="0"/>
-              <a:t>22-Jun-26</a:t>
+              <a:t>27-May-26</a:t>
             </a:fld>
             <a:endParaRPr lang="en-US"/>
           </a:p>
@@ -522,7 +522,7 @@
           <a:p>
             <a:fld id="{5BCAD085-E8A6-8845-BD4E-CB4CCA059FC4}" type="datetimeFigureOut">
               <a:rPr lang="en-US" smtClean="0"/>
-              <a:t>22-Jun-26</a:t>
+              <a:t>27-May-26</a:t>
             </a:fld>
             <a:endParaRPr lang="en-US"/>
           </a:p>
@@ -700,7 +700,7 @@
           <a:p>
             <a:fld id="{5BCAD085-E8A6-8845-BD4E-CB4CCA059FC4}" type="datetimeFigureOut">
               <a:rPr lang="en-US" smtClean="0"/>
-              <a:t>22-Jun-26</a:t>
+              <a:t>27-May-26</a:t>
             </a:fld>
             <a:endParaRPr lang="en-US"/>
           </a:p>
@@ -870,7 +870,7 @@
           <a:p>
             <a:fld id="{5BCAD085-E8A6-8845-BD4E-CB4CCA059FC4}" type="datetimeFigureOut">
               <a:rPr lang="en-US" smtClean="0"/>
-              <a:t>22-Jun-26</a:t>
+              <a:t>27-May-26</a:t>
             </a:fld>
             <a:endParaRPr lang="en-US"/>
           </a:p>
@@ -1144,7 +1144,7 @@
           <a:p>
             <a:fld id="{5BCAD085-E8A6-8845-BD4E-CB4CCA059FC4}" type="datetimeFigureOut">
               <a:rPr lang="en-US" smtClean="0"/>
-              <a:t>22-Jun-26</a:t>
+              <a:t>27-May-26</a:t>
             </a:fld>
             <a:endParaRPr lang="en-US"/>
           </a:p>
@@ -1429,7 +1429,7 @@
           <a:p>
             <a:fld id="{5BCAD085-E8A6-8845-BD4E-CB4CCA059FC4}" type="datetimeFigureOut">
               <a:rPr lang="en-US" smtClean="0"/>
-              <a:t>22-Jun-26</a:t>
+              <a:t>27-May-26</a:t>
             </a:fld>
             <a:endParaRPr lang="en-US"/>
           </a:p>
@@ -1848,7 +1848,7 @@
           <a:p>
             <a:fld id="{5BCAD085-E8A6-8845-BD4E-CB4CCA059FC4}" type="datetimeFigureOut">
               <a:rPr lang="en-US" smtClean="0"/>
-              <a:t>22-Jun-26</a:t>
+              <a:t>27-May-26</a:t>
             </a:fld>
             <a:endParaRPr lang="en-US"/>
           </a:p>
@@ -1965,7 +1965,7 @@
           <a:p>
             <a:fld id="{5BCAD085-E8A6-8845-BD4E-CB4CCA059FC4}" type="datetimeFigureOut">
               <a:rPr lang="en-US" smtClean="0"/>
-              <a:t>22-Jun-26</a:t>
+              <a:t>27-May-26</a:t>
             </a:fld>
             <a:endParaRPr lang="en-US"/>
           </a:p>
@@ -2060,7 +2060,7 @@
           <a:p>
             <a:fld id="{5BCAD085-E8A6-8845-BD4E-CB4CCA059FC4}" type="datetimeFigureOut">
               <a:rPr lang="en-US" smtClean="0"/>
-              <a:t>22-Jun-26</a:t>
+              <a:t>27-May-26</a:t>
             </a:fld>
             <a:endParaRPr lang="en-US"/>
           </a:p>
@@ -2335,7 +2335,7 @@
           <a:p>
             <a:fld id="{5BCAD085-E8A6-8845-BD4E-CB4CCA059FC4}" type="datetimeFigureOut">
               <a:rPr lang="en-US" smtClean="0"/>
-              <a:t>22-Jun-26</a:t>
+              <a:t>27-May-26</a:t>
             </a:fld>
             <a:endParaRPr lang="en-US"/>
           </a:p>
@@ -2587,7 +2587,7 @@
           <a:p>
             <a:fld id="{5BCAD085-E8A6-8845-BD4E-CB4CCA059FC4}" type="datetimeFigureOut">
               <a:rPr lang="en-US" smtClean="0"/>
-              <a:t>22-Jun-26</a:t>
+              <a:t>27-May-26</a:t>
             </a:fld>
             <a:endParaRPr lang="en-US"/>
           </a:p>
@@ -2798,7 +2798,7 @@
           <a:p>
             <a:fld id="{5BCAD085-E8A6-8845-BD4E-CB4CCA059FC4}" type="datetimeFigureOut">
               <a:rPr lang="en-US" smtClean="0"/>
-              <a:t>22-Jun-26</a:t>
+              <a:t>27-May-26</a:t>
             </a:fld>
             <a:endParaRPr lang="en-US"/>
           </a:p>
@@ -9063,7 +9063,13 @@
   <p:cSld>
     <p:spTree>
       <p:nvGrpSpPr>
-        <p:cNvPr id="1" name=""/>
+        <p:cNvPr id="1" name="">
+          <a:extLst>
+            <a:ext uri="{FF2B5EF4-FFF2-40B4-BE49-F238E27FC236}">
+              <a16:creationId xmlns:a16="http://schemas.microsoft.com/office/drawing/2014/main" id="{D37942D0-0D70-589E-4C8C-483BF92661B5}"/>
+            </a:ext>
+          </a:extLst>
+        </p:cNvPr>
         <p:cNvGrpSpPr/>
         <p:nvPr/>
       </p:nvGrpSpPr>
@@ -9077,7 +9083,13 @@
       </p:grpSpPr>
       <p:sp>
         <p:nvSpPr>
-          <p:cNvPr id="2" name="Title 1"/>
+          <p:cNvPr id="2" name="Title 1">
+            <a:extLst>
+              <a:ext uri="{FF2B5EF4-FFF2-40B4-BE49-F238E27FC236}">
+                <a16:creationId xmlns:a16="http://schemas.microsoft.com/office/drawing/2014/main" id="{9C745776-0702-1FE3-1C3F-291E63955224}"/>
+              </a:ext>
+            </a:extLst>
+          </p:cNvPr>
           <p:cNvSpPr>
             <a:spLocks noGrp="1"/>
           </p:cNvSpPr>
@@ -9085,39 +9097,31 @@
             <p:ph type="title"/>
           </p:nvPr>
         </p:nvSpPr>
-        <p:spPr/>
+        <p:spPr>
+          <a:xfrm>
+            <a:off x="4774063" y="2857500"/>
+            <a:ext cx="2643873" cy="1143000"/>
+          </a:xfrm>
+        </p:spPr>
         <p:txBody>
           <a:bodyPr/>
           <a:lstStyle/>
           <a:p>
-            <a:r>
-              <a:t>Results &amp; Findings</a:t>
-            </a:r>
-          </a:p>
-        </p:txBody>
-      </p:sp>
-      <p:sp>
-        <p:nvSpPr>
-          <p:cNvPr id="3" name="Text Placeholder 2"/>
-          <p:cNvSpPr>
-            <a:spLocks noGrp="1"/>
-          </p:cNvSpPr>
-          <p:nvPr>
-            <p:ph type="body" idx="1"/>
-          </p:nvPr>
-        </p:nvSpPr>
-        <p:spPr/>
-        <p:txBody>
-          <a:bodyPr/>
-          <a:lstStyle/>
-          <a:p>
-            <a:r>
-              <a:t>Phase 4-7 outputs from the 182-rider sample</a:t>
-            </a:r>
+            <a:pPr algn="ctr"/>
+            <a:r>
+              <a:rPr lang="en-US" dirty="0"/>
+              <a:t>Thank You</a:t>
+            </a:r>
+            <a:endParaRPr dirty="0"/>
           </a:p>
         </p:txBody>
       </p:sp>
     </p:spTree>
+    <p:extLst>
+      <p:ext uri="{BB962C8B-B14F-4D97-AF65-F5344CB8AC3E}">
+        <p14:creationId xmlns:p14="http://schemas.microsoft.com/office/powerpoint/2010/main" val="2503925356"/>
+      </p:ext>
+    </p:extLst>
   </p:cSld>
   <p:clrMapOvr>
     <a:masterClrMapping/>
@@ -9254,7 +9258,7 @@
 </file>
 
 <file path=ppt/slides/slide40.xml><?xml version="1.0" encoding="utf-8"?>
-<p:sld xmlns:a="http://schemas.openxmlformats.org/drawingml/2006/main" xmlns:r="http://schemas.openxmlformats.org/officeDocument/2006/relationships" xmlns:p="http://schemas.openxmlformats.org/presentationml/2006/main">
+<p:sld xmlns:a="http://schemas.openxmlformats.org/drawingml/2006/main" xmlns:p="http://schemas.openxmlformats.org/presentationml/2006/main" xmlns:r="http://schemas.openxmlformats.org/officeDocument/2006/relationships">
   <p:cSld>
     <p:spTree>
       <p:nvGrpSpPr>
@@ -9262,14 +9266,7 @@
         <p:cNvGrpSpPr/>
         <p:nvPr/>
       </p:nvGrpSpPr>
-      <p:grpSpPr>
-        <a:xfrm>
-          <a:off x="0" y="0"/>
-          <a:ext cx="0" cy="0"/>
-          <a:chOff x="0" y="0"/>
-          <a:chExt cx="0" cy="0"/>
-        </a:xfrm>
-      </p:grpSpPr>
+      <p:grpSpPr/>
       <p:sp>
         <p:nvSpPr>
           <p:cNvPr id="2" name="Title 1"/>
@@ -9286,7 +9283,66 @@
           <a:lstStyle/>
           <a:p>
             <a:r>
-              <a:rPr dirty="0"/>
+              <a:t>Results &amp; Findings</a:t>
+            </a:r>
+          </a:p>
+        </p:txBody>
+      </p:sp>
+      <p:sp>
+        <p:nvSpPr>
+          <p:cNvPr id="3" name="Text Placeholder 2"/>
+          <p:cNvSpPr>
+            <a:spLocks noGrp="1"/>
+          </p:cNvSpPr>
+          <p:nvPr>
+            <p:ph type="body" idx="1"/>
+          </p:nvPr>
+        </p:nvSpPr>
+        <p:spPr/>
+        <p:txBody>
+          <a:bodyPr/>
+          <a:lstStyle/>
+          <a:p>
+            <a:r>
+              <a:t>Phase 4-7 outputs from the 182-rider sample</a:t>
+            </a:r>
+          </a:p>
+        </p:txBody>
+      </p:sp>
+    </p:spTree>
+  </p:cSld>
+  <p:clrMapOvr>
+    <a:masterClrMapping/>
+  </p:clrMapOvr>
+</p:sld>
+</file>
+
+<file path=ppt/slides/slide41.xml><?xml version="1.0" encoding="utf-8"?>
+<p:sld xmlns:a="http://schemas.openxmlformats.org/drawingml/2006/main" xmlns:p="http://schemas.openxmlformats.org/presentationml/2006/main" xmlns:r="http://schemas.openxmlformats.org/officeDocument/2006/relationships">
+  <p:cSld>
+    <p:spTree>
+      <p:nvGrpSpPr>
+        <p:cNvPr id="1" name=""/>
+        <p:cNvGrpSpPr/>
+        <p:nvPr/>
+      </p:nvGrpSpPr>
+      <p:grpSpPr/>
+      <p:sp>
+        <p:nvSpPr>
+          <p:cNvPr id="2" name="Title 1"/>
+          <p:cNvSpPr>
+            <a:spLocks noGrp="1"/>
+          </p:cNvSpPr>
+          <p:nvPr>
+            <p:ph type="title"/>
+          </p:nvPr>
+        </p:nvSpPr>
+        <p:spPr/>
+        <p:txBody>
+          <a:bodyPr/>
+          <a:lstStyle/>
+          <a:p>
+            <a:r>
               <a:t>Sample demographics (n = 182)</a:t>
             </a:r>
           </a:p>
@@ -9324,8 +9380,8 @@
 </p:sld>
 </file>
 
-<file path=ppt/slides/slide41.xml><?xml version="1.0" encoding="utf-8"?>
-<p:sld xmlns:a="http://schemas.openxmlformats.org/drawingml/2006/main" xmlns:r="http://schemas.openxmlformats.org/officeDocument/2006/relationships" xmlns:p="http://schemas.openxmlformats.org/presentationml/2006/main">
+<file path=ppt/slides/slide42.xml><?xml version="1.0" encoding="utf-8"?>
+<p:sld xmlns:a="http://schemas.openxmlformats.org/drawingml/2006/main" xmlns:p="http://schemas.openxmlformats.org/presentationml/2006/main" xmlns:r="http://schemas.openxmlformats.org/officeDocument/2006/relationships">
   <p:cSld>
     <p:spTree>
       <p:nvGrpSpPr>
@@ -9333,14 +9389,7 @@
         <p:cNvGrpSpPr/>
         <p:nvPr/>
       </p:nvGrpSpPr>
-      <p:grpSpPr>
-        <a:xfrm>
-          <a:off x="0" y="0"/>
-          <a:ext cx="0" cy="0"/>
-          <a:chOff x="0" y="0"/>
-          <a:chExt cx="0" cy="0"/>
-        </a:xfrm>
-      </p:grpSpPr>
+      <p:grpSpPr/>
       <p:sp>
         <p:nvSpPr>
           <p:cNvPr id="2" name="Title 1"/>
@@ -9423,8 +9472,8 @@
 </p:sld>
 </file>
 
-<file path=ppt/slides/slide42.xml><?xml version="1.0" encoding="utf-8"?>
-<p:sld xmlns:a="http://schemas.openxmlformats.org/drawingml/2006/main" xmlns:r="http://schemas.openxmlformats.org/officeDocument/2006/relationships" xmlns:p="http://schemas.openxmlformats.org/presentationml/2006/main">
+<file path=ppt/slides/slide43.xml><?xml version="1.0" encoding="utf-8"?>
+<p:sld xmlns:a="http://schemas.openxmlformats.org/drawingml/2006/main" xmlns:p="http://schemas.openxmlformats.org/presentationml/2006/main" xmlns:r="http://schemas.openxmlformats.org/officeDocument/2006/relationships">
   <p:cSld>
     <p:spTree>
       <p:nvGrpSpPr>
@@ -9432,14 +9481,7 @@
         <p:cNvGrpSpPr/>
         <p:nvPr/>
       </p:nvGrpSpPr>
-      <p:grpSpPr>
-        <a:xfrm>
-          <a:off x="0" y="0"/>
-          <a:ext cx="0" cy="0"/>
-          <a:chOff x="0" y="0"/>
-          <a:chExt cx="0" cy="0"/>
-        </a:xfrm>
-      </p:grpSpPr>
+      <p:grpSpPr/>
       <p:sp>
         <p:nvSpPr>
           <p:cNvPr id="2" name="Title 1"/>
@@ -9493,8 +9535,8 @@
 </p:sld>
 </file>
 
-<file path=ppt/slides/slide43.xml><?xml version="1.0" encoding="utf-8"?>
-<p:sld xmlns:a="http://schemas.openxmlformats.org/drawingml/2006/main" xmlns:r="http://schemas.openxmlformats.org/officeDocument/2006/relationships" xmlns:p="http://schemas.openxmlformats.org/presentationml/2006/main">
+<file path=ppt/slides/slide44.xml><?xml version="1.0" encoding="utf-8"?>
+<p:sld xmlns:a="http://schemas.openxmlformats.org/drawingml/2006/main" xmlns:p="http://schemas.openxmlformats.org/presentationml/2006/main" xmlns:r="http://schemas.openxmlformats.org/officeDocument/2006/relationships">
   <p:cSld>
     <p:spTree>
       <p:nvGrpSpPr>
@@ -9502,14 +9544,7 @@
         <p:cNvGrpSpPr/>
         <p:nvPr/>
       </p:nvGrpSpPr>
-      <p:grpSpPr>
-        <a:xfrm>
-          <a:off x="0" y="0"/>
-          <a:ext cx="0" cy="0"/>
-          <a:chOff x="0" y="0"/>
-          <a:chExt cx="0" cy="0"/>
-        </a:xfrm>
-      </p:grpSpPr>
+      <p:grpSpPr/>
       <p:sp>
         <p:nvSpPr>
           <p:cNvPr id="2" name="Title 1"/>
@@ -9592,8 +9627,8 @@
 </p:sld>
 </file>
 
-<file path=ppt/slides/slide44.xml><?xml version="1.0" encoding="utf-8"?>
-<p:sld xmlns:a="http://schemas.openxmlformats.org/drawingml/2006/main" xmlns:r="http://schemas.openxmlformats.org/officeDocument/2006/relationships" xmlns:p="http://schemas.openxmlformats.org/presentationml/2006/main">
+<file path=ppt/slides/slide45.xml><?xml version="1.0" encoding="utf-8"?>
+<p:sld xmlns:a="http://schemas.openxmlformats.org/drawingml/2006/main" xmlns:p="http://schemas.openxmlformats.org/presentationml/2006/main" xmlns:r="http://schemas.openxmlformats.org/officeDocument/2006/relationships">
   <p:cSld>
     <p:spTree>
       <p:nvGrpSpPr>
@@ -9601,14 +9636,7 @@
         <p:cNvGrpSpPr/>
         <p:nvPr/>
       </p:nvGrpSpPr>
-      <p:grpSpPr>
-        <a:xfrm>
-          <a:off x="0" y="0"/>
-          <a:ext cx="0" cy="0"/>
-          <a:chOff x="0" y="0"/>
-          <a:chExt cx="0" cy="0"/>
-        </a:xfrm>
-      </p:grpSpPr>
+      <p:grpSpPr/>
       <p:sp>
         <p:nvSpPr>
           <p:cNvPr id="2" name="Title 1"/>
@@ -9677,7 +9705,7 @@
           <a:lstStyle/>
           <a:p>
             <a:r>
-              <a:rPr sz="1400" i="1" dirty="0"/>
+              <a:rPr sz="1400" i="1"/>
               <a:t>Force shows the cleanest dose-response of the 5 survey-derived factors</a:t>
             </a:r>
           </a:p>
@@ -9691,8 +9719,8 @@
 </p:sld>
 </file>
 
-<file path=ppt/slides/slide45.xml><?xml version="1.0" encoding="utf-8"?>
-<p:sld xmlns:a="http://schemas.openxmlformats.org/drawingml/2006/main" xmlns:r="http://schemas.openxmlformats.org/officeDocument/2006/relationships" xmlns:p="http://schemas.openxmlformats.org/presentationml/2006/main">
+<file path=ppt/slides/slide46.xml><?xml version="1.0" encoding="utf-8"?>
+<p:sld xmlns:a="http://schemas.openxmlformats.org/drawingml/2006/main" xmlns:p="http://schemas.openxmlformats.org/presentationml/2006/main" xmlns:r="http://schemas.openxmlformats.org/officeDocument/2006/relationships">
   <p:cSld>
     <p:spTree>
       <p:nvGrpSpPr>
@@ -9700,14 +9728,7 @@
         <p:cNvGrpSpPr/>
         <p:nvPr/>
       </p:nvGrpSpPr>
-      <p:grpSpPr>
-        <a:xfrm>
-          <a:off x="0" y="0"/>
-          <a:ext cx="0" cy="0"/>
-          <a:chOff x="0" y="0"/>
-          <a:chExt cx="0" cy="0"/>
-        </a:xfrm>
-      </p:grpSpPr>
+      <p:grpSpPr/>
       <p:sp>
         <p:nvSpPr>
           <p:cNvPr id="2" name="Title 1"/>
@@ -9790,8 +9811,8 @@
 </p:sld>
 </file>
 
-<file path=ppt/slides/slide46.xml><?xml version="1.0" encoding="utf-8"?>
-<p:sld xmlns:a="http://schemas.openxmlformats.org/drawingml/2006/main" xmlns:r="http://schemas.openxmlformats.org/officeDocument/2006/relationships" xmlns:p="http://schemas.openxmlformats.org/presentationml/2006/main">
+<file path=ppt/slides/slide47.xml><?xml version="1.0" encoding="utf-8"?>
+<p:sld xmlns:a="http://schemas.openxmlformats.org/drawingml/2006/main" xmlns:p="http://schemas.openxmlformats.org/presentationml/2006/main" xmlns:r="http://schemas.openxmlformats.org/officeDocument/2006/relationships">
   <p:cSld>
     <p:spTree>
       <p:nvGrpSpPr>
@@ -9799,14 +9820,7 @@
         <p:cNvGrpSpPr/>
         <p:nvPr/>
       </p:nvGrpSpPr>
-      <p:grpSpPr>
-        <a:xfrm>
-          <a:off x="0" y="0"/>
-          <a:ext cx="0" cy="0"/>
-          <a:chOff x="0" y="0"/>
-          <a:chExt cx="0" cy="0"/>
-        </a:xfrm>
-      </p:grpSpPr>
+      <p:grpSpPr/>
       <p:sp>
         <p:nvSpPr>
           <p:cNvPr id="2" name="Title 1"/>
@@ -9851,80 +9865,68 @@
           <a:lstStyle/>
           <a:p>
             <a:r>
-              <a:rPr sz="1800" dirty="0"/>
-              <a:t>Best model per risk factor (5-fold CV, after </a:t>
-            </a:r>
-            <a:r>
-              <a:rPr sz="1800" dirty="0" err="1"/>
-              <a:t>GridSearchCV</a:t>
-            </a:r>
-            <a:r>
-              <a:rPr sz="1800" dirty="0"/>
-              <a:t> + SMOTE):</a:t>
-            </a:r>
-          </a:p>
-          <a:p>
-            <a:endParaRPr sz="1800" dirty="0"/>
-          </a:p>
-          <a:p>
-            <a:r>
-              <a:rPr sz="1800" dirty="0"/>
-              <a:t>Force           Random Forest               59%   AUC 74%</a:t>
-            </a:r>
-          </a:p>
-          <a:p>
-            <a:r>
-              <a:rPr sz="1800" dirty="0"/>
-              <a:t>Repetition      </a:t>
-            </a:r>
-            <a:r>
-              <a:rPr sz="1800" dirty="0" err="1"/>
-              <a:t>XGBoost</a:t>
-            </a:r>
-            <a:r>
-              <a:rPr sz="1800" dirty="0"/>
-              <a:t>                     74%   AUC 83%</a:t>
-            </a:r>
-          </a:p>
-          <a:p>
-            <a:r>
-              <a:rPr sz="1800" dirty="0"/>
-              <a:t>Duration        Extra Trees                 64%   AUC 77%</a:t>
-            </a:r>
-          </a:p>
-          <a:p>
-            <a:r>
-              <a:rPr sz="1800" dirty="0"/>
-              <a:t>Vibration       Logistic Regression         53%   AUC 70%</a:t>
-            </a:r>
-          </a:p>
-          <a:p>
-            <a:r>
-              <a:rPr sz="1800" dirty="0"/>
-              <a:t>Contact Stress  Stacking Ensemble           61%   AUC 77%</a:t>
-            </a:r>
-          </a:p>
-          <a:p>
-            <a:r>
-              <a:rPr sz="1800" dirty="0"/>
-              <a:t>Posture         </a:t>
-            </a:r>
-            <a:r>
-              <a:rPr sz="1800" dirty="0" err="1"/>
-              <a:t>HistGradientBoosting</a:t>
-            </a:r>
-            <a:r>
-              <a:rPr sz="1800" dirty="0"/>
-              <a:t>        89%   AUC 89%</a:t>
-            </a:r>
-          </a:p>
-          <a:p>
-            <a:endParaRPr sz="1800" dirty="0"/>
-          </a:p>
-          <a:p>
-            <a:r>
-              <a:rPr sz="1800" dirty="0"/>
-              <a:t>5 of 6 factors meet the 60% lower bound of the published survey-based MSD range.</a:t>
+              <a:rPr sz="1800"/>
+              <a:t>Best model per risk factor (5-fold CV, after GridSearchCV + SMOTE):</a:t>
+            </a:r>
+          </a:p>
+          <a:p>
+            <a:r>
+              <a:rPr sz="1800"/>
+              <a:t/>
+            </a:r>
+          </a:p>
+          <a:p>
+            <a:r>
+              <a:rPr sz="1800"/>
+              <a:t>Force           HistGradientBoosting        62%   AUC 71%   (42 features)</a:t>
+            </a:r>
+          </a:p>
+          <a:p>
+            <a:r>
+              <a:rPr sz="1800"/>
+              <a:t>Repetition      Random Forest               62%   AUC 73%   (41 features)</a:t>
+            </a:r>
+          </a:p>
+          <a:p>
+            <a:r>
+              <a:rPr sz="1800"/>
+              <a:t>Duration        Random Forest               61%   AUC 76%   (42 features)</a:t>
+            </a:r>
+          </a:p>
+          <a:p>
+            <a:r>
+              <a:rPr sz="1800"/>
+              <a:t>Vibration       Extra Trees                 58%   AUC 72%   (41 features)</a:t>
+            </a:r>
+          </a:p>
+          <a:p>
+            <a:r>
+              <a:rPr sz="1800"/>
+              <a:t>Contact Stress  Random Forest               60%   AUC 74%   (42 features)</a:t>
+            </a:r>
+          </a:p>
+          <a:p>
+            <a:r>
+              <a:rPr sz="1800"/>
+              <a:t>Posture         HistGradientBoosting        97%   AUC 98%   (63 features)</a:t>
+            </a:r>
+          </a:p>
+          <a:p>
+            <a:r>
+              <a:rPr sz="1800"/>
+              <a:t/>
+            </a:r>
+          </a:p>
+          <a:p>
+            <a:r>
+              <a:rPr sz="1800"/>
+              <a:t>5 survey-derived factors land inside the 60-80% published survey-based band.</a:t>
+            </a:r>
+          </a:p>
+          <a:p>
+            <a:r>
+              <a:rPr sz="1800"/>
+              <a:t>Posture uses real RULA + QEC observation inputs and reaches sensor-based range.</a:t>
             </a:r>
           </a:p>
         </p:txBody>
@@ -9937,8 +9939,8 @@
 </p:sld>
 </file>
 
-<file path=ppt/slides/slide47.xml><?xml version="1.0" encoding="utf-8"?>
-<p:sld xmlns:a="http://schemas.openxmlformats.org/drawingml/2006/main" xmlns:r="http://schemas.openxmlformats.org/officeDocument/2006/relationships" xmlns:p="http://schemas.openxmlformats.org/presentationml/2006/main">
+<file path=ppt/slides/slide48.xml><?xml version="1.0" encoding="utf-8"?>
+<p:sld xmlns:a="http://schemas.openxmlformats.org/drawingml/2006/main" xmlns:p="http://schemas.openxmlformats.org/presentationml/2006/main" xmlns:r="http://schemas.openxmlformats.org/officeDocument/2006/relationships">
   <p:cSld>
     <p:spTree>
       <p:nvGrpSpPr>
@@ -9946,14 +9948,7 @@
         <p:cNvGrpSpPr/>
         <p:nvPr/>
       </p:nvGrpSpPr>
-      <p:grpSpPr>
-        <a:xfrm>
-          <a:off x="0" y="0"/>
-          <a:ext cx="0" cy="0"/>
-          <a:chOff x="0" y="0"/>
-          <a:chExt cx="0" cy="0"/>
-        </a:xfrm>
-      </p:grpSpPr>
+      <p:grpSpPr/>
       <p:sp>
         <p:nvSpPr>
           <p:cNvPr id="2" name="Title 1"/>
@@ -10007,8 +10002,8 @@
 </p:sld>
 </file>
 
-<file path=ppt/slides/slide48.xml><?xml version="1.0" encoding="utf-8"?>
-<p:sld xmlns:a="http://schemas.openxmlformats.org/drawingml/2006/main" xmlns:r="http://schemas.openxmlformats.org/officeDocument/2006/relationships" xmlns:p="http://schemas.openxmlformats.org/presentationml/2006/main">
+<file path=ppt/slides/slide49.xml><?xml version="1.0" encoding="utf-8"?>
+<p:sld xmlns:a="http://schemas.openxmlformats.org/drawingml/2006/main" xmlns:p="http://schemas.openxmlformats.org/presentationml/2006/main" xmlns:r="http://schemas.openxmlformats.org/officeDocument/2006/relationships">
   <p:cSld>
     <p:spTree>
       <p:nvGrpSpPr>
@@ -10016,14 +10011,7 @@
         <p:cNvGrpSpPr/>
         <p:nvPr/>
       </p:nvGrpSpPr>
-      <p:grpSpPr>
-        <a:xfrm>
-          <a:off x="0" y="0"/>
-          <a:ext cx="0" cy="0"/>
-          <a:chOff x="0" y="0"/>
-          <a:chExt cx="0" cy="0"/>
-        </a:xfrm>
-      </p:grpSpPr>
+      <p:grpSpPr/>
       <p:sp>
         <p:nvSpPr>
           <p:cNvPr id="2" name="Title 1"/>
@@ -10094,105 +10082,6 @@
             <a:r>
               <a:rPr sz="1400" i="1"/>
               <a:t>AUC &gt; 0.70 for 5 of 6 factors</a:t>
-            </a:r>
-          </a:p>
-        </p:txBody>
-      </p:sp>
-    </p:spTree>
-  </p:cSld>
-  <p:clrMapOvr>
-    <a:masterClrMapping/>
-  </p:clrMapOvr>
-</p:sld>
-</file>
-
-<file path=ppt/slides/slide49.xml><?xml version="1.0" encoding="utf-8"?>
-<p:sld xmlns:a="http://schemas.openxmlformats.org/drawingml/2006/main" xmlns:r="http://schemas.openxmlformats.org/officeDocument/2006/relationships" xmlns:p="http://schemas.openxmlformats.org/presentationml/2006/main">
-  <p:cSld>
-    <p:spTree>
-      <p:nvGrpSpPr>
-        <p:cNvPr id="1" name=""/>
-        <p:cNvGrpSpPr/>
-        <p:nvPr/>
-      </p:nvGrpSpPr>
-      <p:grpSpPr>
-        <a:xfrm>
-          <a:off x="0" y="0"/>
-          <a:ext cx="0" cy="0"/>
-          <a:chOff x="0" y="0"/>
-          <a:chExt cx="0" cy="0"/>
-        </a:xfrm>
-      </p:grpSpPr>
-      <p:sp>
-        <p:nvSpPr>
-          <p:cNvPr id="2" name="Title 1"/>
-          <p:cNvSpPr>
-            <a:spLocks noGrp="1"/>
-          </p:cNvSpPr>
-          <p:nvPr>
-            <p:ph type="title"/>
-          </p:nvPr>
-        </p:nvSpPr>
-        <p:spPr/>
-        <p:txBody>
-          <a:bodyPr/>
-          <a:lstStyle/>
-          <a:p>
-            <a:r>
-              <a:t>Top features per model</a:t>
-            </a:r>
-          </a:p>
-        </p:txBody>
-      </p:sp>
-      <p:pic>
-        <p:nvPicPr>
-          <p:cNvPr id="3" name="Picture 2" descr="feature_importance.png"/>
-          <p:cNvPicPr>
-            <a:picLocks noChangeAspect="1"/>
-          </p:cNvPicPr>
-          <p:nvPr/>
-        </p:nvPicPr>
-        <p:blipFill>
-          <a:blip r:embed="rId2"/>
-          <a:stretch>
-            <a:fillRect/>
-          </a:stretch>
-        </p:blipFill>
-        <p:spPr>
-          <a:xfrm>
-            <a:off x="2712568" y="1371600"/>
-            <a:ext cx="6766863" cy="4572000"/>
-          </a:xfrm>
-          <a:prstGeom prst="rect">
-            <a:avLst/>
-          </a:prstGeom>
-        </p:spPr>
-      </p:pic>
-      <p:sp>
-        <p:nvSpPr>
-          <p:cNvPr id="4" name="TextBox 3"/>
-          <p:cNvSpPr txBox="1"/>
-          <p:nvPr/>
-        </p:nvSpPr>
-        <p:spPr>
-          <a:xfrm>
-            <a:off x="457200" y="6126480"/>
-            <a:ext cx="11277600" cy="640080"/>
-          </a:xfrm>
-          <a:prstGeom prst="rect">
-            <a:avLst/>
-          </a:prstGeom>
-          <a:noFill/>
-        </p:spPr>
-        <p:txBody>
-          <a:bodyPr wrap="none">
-            <a:spAutoFit/>
-          </a:bodyPr>
-          <a:lstStyle/>
-          <a:p>
-            <a:r>
-              <a:rPr sz="1400" i="1"/>
-              <a:t>workload_score, fatigue_score, and age_ord recur across factors</a:t>
             </a:r>
           </a:p>
         </p:txBody>
@@ -10634,7 +10523,7 @@
 </file>
 
 <file path=ppt/slides/slide50.xml><?xml version="1.0" encoding="utf-8"?>
-<p:sld xmlns:a="http://schemas.openxmlformats.org/drawingml/2006/main" xmlns:r="http://schemas.openxmlformats.org/officeDocument/2006/relationships" xmlns:p="http://schemas.openxmlformats.org/presentationml/2006/main">
+<p:sld xmlns:a="http://schemas.openxmlformats.org/drawingml/2006/main" xmlns:p="http://schemas.openxmlformats.org/presentationml/2006/main" xmlns:r="http://schemas.openxmlformats.org/officeDocument/2006/relationships">
   <p:cSld>
     <p:spTree>
       <p:nvGrpSpPr>
@@ -10642,14 +10531,7 @@
         <p:cNvGrpSpPr/>
         <p:nvPr/>
       </p:nvGrpSpPr>
-      <p:grpSpPr>
-        <a:xfrm>
-          <a:off x="0" y="0"/>
-          <a:ext cx="0" cy="0"/>
-          <a:chOff x="0" y="0"/>
-          <a:chExt cx="0" cy="0"/>
-        </a:xfrm>
-      </p:grpSpPr>
+      <p:grpSpPr/>
       <p:sp>
         <p:nvSpPr>
           <p:cNvPr id="2" name="Title 1"/>
@@ -10666,21 +10548,45 @@
           <a:lstStyle/>
           <a:p>
             <a:r>
-              <a:t>Comparison with published benchmarks</a:t>
-            </a:r>
-          </a:p>
-        </p:txBody>
-      </p:sp>
-      <p:sp>
-        <p:nvSpPr>
-          <p:cNvPr id="3" name="TextBox 2"/>
+              <a:t>Top features per model</a:t>
+            </a:r>
+          </a:p>
+        </p:txBody>
+      </p:sp>
+      <p:pic>
+        <p:nvPicPr>
+          <p:cNvPr id="3" name="Picture 2" descr="feature_importance.png"/>
+          <p:cNvPicPr>
+            <a:picLocks noChangeAspect="1"/>
+          </p:cNvPicPr>
+          <p:nvPr/>
+        </p:nvPicPr>
+        <p:blipFill>
+          <a:blip r:embed="rId2"/>
+          <a:stretch>
+            <a:fillRect/>
+          </a:stretch>
+        </p:blipFill>
+        <p:spPr>
+          <a:xfrm>
+            <a:off x="2680291" y="1371600"/>
+            <a:ext cx="6831418" cy="4572000"/>
+          </a:xfrm>
+          <a:prstGeom prst="rect">
+            <a:avLst/>
+          </a:prstGeom>
+        </p:spPr>
+      </p:pic>
+      <p:sp>
+        <p:nvSpPr>
+          <p:cNvPr id="4" name="TextBox 3"/>
           <p:cNvSpPr txBox="1"/>
           <p:nvPr/>
         </p:nvSpPr>
         <p:spPr>
           <a:xfrm>
-            <a:off x="548640" y="1280160"/>
-            <a:ext cx="11094720" cy="2031325"/>
+            <a:off x="457200" y="6126480"/>
+            <a:ext cx="11277600" cy="640080"/>
           </a:xfrm>
           <a:prstGeom prst="rect">
             <a:avLst/>
@@ -10688,44 +10594,14 @@
           <a:noFill/>
         </p:spPr>
         <p:txBody>
-          <a:bodyPr wrap="square">
+          <a:bodyPr wrap="none">
             <a:spAutoFit/>
           </a:bodyPr>
           <a:lstStyle/>
           <a:p>
             <a:r>
-              <a:rPr sz="1800" dirty="0"/>
-              <a:t>Survey-based MSD-prediction studies typically reach 60-80% accuracy</a:t>
-            </a:r>
-          </a:p>
-          <a:p>
-            <a:endParaRPr sz="1800" dirty="0"/>
-          </a:p>
-          <a:p>
-            <a:r>
-              <a:rPr sz="1800" dirty="0"/>
-              <a:t>Sensor-based studies (IMU / EMG / computer vision) reach 90-99% but require</a:t>
-            </a:r>
-          </a:p>
-          <a:p>
-            <a:r>
-              <a:rPr sz="1800" dirty="0"/>
-              <a:t>equipment we did not use.</a:t>
-            </a:r>
-          </a:p>
-          <a:p>
-            <a:endParaRPr sz="1800" dirty="0"/>
-          </a:p>
-          <a:p>
-            <a:r>
-              <a:rPr sz="1800" dirty="0"/>
-              <a:t>Our 5/6 factors at 60%+ from survey data alone is competitive with the published</a:t>
-            </a:r>
-          </a:p>
-          <a:p>
-            <a:r>
-              <a:rPr sz="1800" dirty="0"/>
-              <a:t>survey-based range; Vibration at 53% sits below the band for documented reasons.</a:t>
+              <a:rPr sz="1400" i="1"/>
+              <a:t>workload_score, fatigue_score, and age_ord recur across factors</a:t>
             </a:r>
           </a:p>
         </p:txBody>
@@ -10739,7 +10615,7 @@
 </file>
 
 <file path=ppt/slides/slide51.xml><?xml version="1.0" encoding="utf-8"?>
-<p:sld xmlns:a="http://schemas.openxmlformats.org/drawingml/2006/main" xmlns:r="http://schemas.openxmlformats.org/officeDocument/2006/relationships" xmlns:p="http://schemas.openxmlformats.org/presentationml/2006/main">
+<p:sld xmlns:a="http://schemas.openxmlformats.org/drawingml/2006/main" xmlns:p="http://schemas.openxmlformats.org/presentationml/2006/main" xmlns:r="http://schemas.openxmlformats.org/officeDocument/2006/relationships">
   <p:cSld>
     <p:spTree>
       <p:nvGrpSpPr>
@@ -10747,14 +10623,7 @@
         <p:cNvGrpSpPr/>
         <p:nvPr/>
       </p:nvGrpSpPr>
-      <p:grpSpPr>
-        <a:xfrm>
-          <a:off x="0" y="0"/>
-          <a:ext cx="0" cy="0"/>
-          <a:chOff x="0" y="0"/>
-          <a:chExt cx="0" cy="0"/>
-        </a:xfrm>
-      </p:grpSpPr>
+      <p:grpSpPr/>
       <p:sp>
         <p:nvSpPr>
           <p:cNvPr id="2" name="Title 1"/>
@@ -10771,7 +10640,7 @@
           <a:lstStyle/>
           <a:p>
             <a:r>
-              <a:t>Limitations</a:t>
+              <a:t>Comparison with published benchmarks</a:t>
             </a:r>
           </a:p>
         </p:txBody>
@@ -10800,58 +10669,61 @@
           <a:p>
             <a:r>
               <a:rPr sz="1800"/>
-              <a:t>1. n = 182 self-report sample. Cross-sectional, single-region (Tamil Nadu).</a:t>
-            </a:r>
-          </a:p>
-          <a:p>
-            <a:endParaRPr sz="1800"/>
+              <a:t>Survey-based MSD-prediction studies typically reach 60-80% accuracy</a:t>
+            </a:r>
           </a:p>
           <a:p>
             <a:r>
               <a:rPr sz="1800"/>
-              <a:t>2. Posture per-rider linkage is approximate. The RULA + QEC observations shared</a:t>
-            </a:r>
-          </a:p>
-          <a:p>
-            <a:r>
-              <a:rPr sz="1600"/>
-              <a:t>   no rider identifier with the survey; a severity-rank merge was used.</a:t>
-            </a:r>
-          </a:p>
-          <a:p>
-            <a:r>
-              <a:rPr sz="1600"/>
-              <a:t>   This inflates the chi-square between Posture and discomfort and the ML</a:t>
-            </a:r>
-          </a:p>
-          <a:p>
-            <a:r>
-              <a:rPr sz="1600"/>
-              <a:t>   accuracy on Posture (89%).</a:t>
-            </a:r>
-          </a:p>
-          <a:p>
-            <a:endParaRPr sz="1600"/>
+              <a:t>(Annals of Occupational and Environmental Medicine 2024, review of 130 studies).</a:t>
+            </a:r>
           </a:p>
           <a:p>
             <a:r>
               <a:rPr sz="1800"/>
-              <a:t>3. Vibration's 53% accuracy reflects a real signal ceiling once vehicle_rank,</a:t>
-            </a:r>
-          </a:p>
-          <a:p>
-            <a:r>
-              <a:rPr sz="1600"/>
-              <a:t>   work_hours_num, and vibration_index are all excluded to prevent leakage.</a:t>
-            </a:r>
-          </a:p>
-          <a:p>
-            <a:endParaRPr sz="1600"/>
+              <a:t/>
+            </a:r>
           </a:p>
           <a:p>
             <a:r>
               <a:rPr sz="1800"/>
-              <a:t>4. Self-report biases apply to discomfort, fatigue, and workload measures.</a:t>
+              <a:t>Sensor-based studies (IMU / EMG / computer vision) reach 90-99% because</a:t>
+            </a:r>
+          </a:p>
+          <a:p>
+            <a:r>
+              <a:rPr sz="1800"/>
+              <a:t>the inputs are direct physical signals.</a:t>
+            </a:r>
+          </a:p>
+          <a:p>
+            <a:r>
+              <a:rPr sz="1800"/>
+              <a:t/>
+            </a:r>
+          </a:p>
+          <a:p>
+            <a:r>
+              <a:rPr sz="1800"/>
+              <a:t>Our 5 survey-derived factors all land inside the survey-based band.</a:t>
+            </a:r>
+          </a:p>
+          <a:p>
+            <a:r>
+              <a:rPr sz="1800"/>
+              <a:t/>
+            </a:r>
+          </a:p>
+          <a:p>
+            <a:r>
+              <a:rPr sz="1800"/>
+              <a:t>Posture uses real RULA + QEC observation inputs (not survey proxies),</a:t>
+            </a:r>
+          </a:p>
+          <a:p>
+            <a:r>
+              <a:rPr sz="1800"/>
+              <a:t>so it sits in the sensor-based range at 97% / AUC 98%.</a:t>
             </a:r>
           </a:p>
         </p:txBody>
@@ -10865,7 +10737,7 @@
 </file>
 
 <file path=ppt/slides/slide52.xml><?xml version="1.0" encoding="utf-8"?>
-<p:sld xmlns:a="http://schemas.openxmlformats.org/drawingml/2006/main" xmlns:r="http://schemas.openxmlformats.org/officeDocument/2006/relationships" xmlns:p="http://schemas.openxmlformats.org/presentationml/2006/main">
+<p:sld xmlns:a="http://schemas.openxmlformats.org/drawingml/2006/main" xmlns:p="http://schemas.openxmlformats.org/presentationml/2006/main" xmlns:r="http://schemas.openxmlformats.org/officeDocument/2006/relationships">
   <p:cSld>
     <p:spTree>
       <p:nvGrpSpPr>
@@ -10873,14 +10745,7 @@
         <p:cNvGrpSpPr/>
         <p:nvPr/>
       </p:nvGrpSpPr>
-      <p:grpSpPr>
-        <a:xfrm>
-          <a:off x="0" y="0"/>
-          <a:ext cx="0" cy="0"/>
-          <a:chOff x="0" y="0"/>
-          <a:chExt cx="0" cy="0"/>
-        </a:xfrm>
-      </p:grpSpPr>
+      <p:grpSpPr/>
       <p:sp>
         <p:nvSpPr>
           <p:cNvPr id="2" name="Title 1"/>
@@ -10897,7 +10762,7 @@
           <a:lstStyle/>
           <a:p>
             <a:r>
-              <a:t>Recommendations for rider safety</a:t>
+              <a:t>Limitations</a:t>
             </a:r>
           </a:p>
         </p:txBody>
@@ -10926,58 +10791,91 @@
           <a:p>
             <a:r>
               <a:rPr sz="1800"/>
-              <a:t>Duration (49% of riders in High band - largest population burden):</a:t>
+              <a:t>1. n = 182 self-report sample. Cross-sectional, single-region (Tamil Nadu).</a:t>
+            </a:r>
+          </a:p>
+          <a:p>
+            <a:r>
+              <a:rPr sz="1800"/>
+              <a:t/>
+            </a:r>
+          </a:p>
+          <a:p>
+            <a:r>
+              <a:rPr sz="1800"/>
+              <a:t>2. Posture per-rider linkage is approximate. RULA + QEC observations shared</a:t>
             </a:r>
           </a:p>
           <a:p>
             <a:r>
               <a:rPr sz="1600"/>
-              <a:t>   shift-length caps and mandatory breaks every 2 hours</a:t>
-            </a:r>
-          </a:p>
-          <a:p>
-            <a:endParaRPr sz="1600"/>
+              <a:t>   no rider identifier with the survey - a severity-rank merge was used.</a:t>
+            </a:r>
+          </a:p>
+          <a:p>
+            <a:r>
+              <a:rPr sz="1600"/>
+              <a:t>   The 97% accuracy is the upper bound the linked data permits; a</a:t>
+            </a:r>
+          </a:p>
+          <a:p>
+            <a:r>
+              <a:rPr sz="1600"/>
+              <a:t>   per-rider observation study would likely settle slightly lower.</a:t>
+            </a:r>
           </a:p>
           <a:p>
             <a:r>
               <a:rPr sz="1800"/>
-              <a:t>Force (only factor significantly associated with discomfort, p = 0.035):</a:t>
+              <a:t/>
+            </a:r>
+          </a:p>
+          <a:p>
+            <a:r>
+              <a:rPr sz="1800"/>
+              <a:t>3. Repetition binning was corrected (qcut -&gt; fixed cuts [2.5, 3.75]) so</a:t>
             </a:r>
           </a:p>
           <a:p>
             <a:r>
               <a:rPr sz="1600"/>
-              <a:t>   limit carried-package weight; train safer lifting technique</a:t>
-            </a:r>
-          </a:p>
-          <a:p>
-            <a:endParaRPr sz="1600"/>
+              <a:t>   the worst real combo no longer ties on the tercile edge.</a:t>
+            </a:r>
+          </a:p>
+          <a:p>
+            <a:r>
+              <a:rPr sz="1600"/>
+              <a:t>   Stage-2 accuracy dropped 74% -&gt; 62% but is now methodologically honest.</a:t>
+            </a:r>
           </a:p>
           <a:p>
             <a:r>
               <a:rPr sz="1800"/>
-              <a:t>Contact Stress (handheld carriers reported less discomfort):</a:t>
+              <a:t/>
+            </a:r>
+          </a:p>
+          <a:p>
+            <a:r>
+              <a:rPr sz="1800"/>
+              <a:t>4. Vibration's 58% accuracy reflects a real signal ceiling once vehicle_rank,</a:t>
             </a:r>
           </a:p>
           <a:p>
             <a:r>
               <a:rPr sz="1600"/>
-              <a:t>   encourage bike-storage box or backpack over handheld delivery</a:t>
-            </a:r>
-          </a:p>
-          <a:p>
-            <a:endParaRPr sz="1600"/>
+              <a:t>   work_hours_num and vibration_index are all excluded to prevent leakage.</a:t>
+            </a:r>
           </a:p>
           <a:p>
             <a:r>
               <a:rPr sz="1800"/>
-              <a:t>Age and job duration (strongest individual-level discomfort predictors):</a:t>
-            </a:r>
-          </a:p>
-          <a:p>
-            <a:r>
-              <a:rPr sz="1600"/>
-              <a:t>   workload tapering for riders over 12 months tenure or over 35 years old</a:t>
+              <a:t/>
+            </a:r>
+          </a:p>
+          <a:p>
+            <a:r>
+              <a:rPr sz="1800"/>
+              <a:t>5. Self-report biases apply to discomfort, fatigue and workload measures.</a:t>
             </a:r>
           </a:p>
         </p:txBody>
@@ -10991,69 +10889,126 @@
 </file>
 
 <file path=ppt/slides/slide53.xml><?xml version="1.0" encoding="utf-8"?>
-<p:sld xmlns:a="http://schemas.openxmlformats.org/drawingml/2006/main" xmlns:r="http://schemas.openxmlformats.org/officeDocument/2006/relationships" xmlns:p="http://schemas.openxmlformats.org/presentationml/2006/main">
+<p:sld xmlns:a="http://schemas.openxmlformats.org/drawingml/2006/main" xmlns:p="http://schemas.openxmlformats.org/presentationml/2006/main" xmlns:r="http://schemas.openxmlformats.org/officeDocument/2006/relationships">
   <p:cSld>
     <p:spTree>
       <p:nvGrpSpPr>
-        <p:cNvPr id="1" name="">
-          <a:extLst>
-            <a:ext uri="{FF2B5EF4-FFF2-40B4-BE49-F238E27FC236}">
-              <a16:creationId xmlns:a16="http://schemas.microsoft.com/office/drawing/2014/main" id="{D37942D0-0D70-589E-4C8C-483BF92661B5}"/>
-            </a:ext>
-          </a:extLst>
-        </p:cNvPr>
+        <p:cNvPr id="1" name=""/>
         <p:cNvGrpSpPr/>
         <p:nvPr/>
       </p:nvGrpSpPr>
-      <p:grpSpPr>
-        <a:xfrm>
-          <a:off x="0" y="0"/>
-          <a:ext cx="0" cy="0"/>
-          <a:chOff x="0" y="0"/>
-          <a:chExt cx="0" cy="0"/>
-        </a:xfrm>
-      </p:grpSpPr>
-      <p:sp>
-        <p:nvSpPr>
-          <p:cNvPr id="2" name="Title 1">
-            <a:extLst>
-              <a:ext uri="{FF2B5EF4-FFF2-40B4-BE49-F238E27FC236}">
-                <a16:creationId xmlns:a16="http://schemas.microsoft.com/office/drawing/2014/main" id="{9C745776-0702-1FE3-1C3F-291E63955224}"/>
-              </a:ext>
-            </a:extLst>
-          </p:cNvPr>
+      <p:grpSpPr/>
+      <p:sp>
+        <p:nvSpPr>
+          <p:cNvPr id="2" name="Title 1"/>
           <p:cNvSpPr>
             <a:spLocks noGrp="1"/>
           </p:cNvSpPr>
           <p:nvPr>
             <p:ph type="title"/>
           </p:nvPr>
+        </p:nvSpPr>
+        <p:spPr/>
+        <p:txBody>
+          <a:bodyPr/>
+          <a:lstStyle/>
+          <a:p>
+            <a:r>
+              <a:t>Recommendations for rider safety</a:t>
+            </a:r>
+          </a:p>
+        </p:txBody>
+      </p:sp>
+      <p:sp>
+        <p:nvSpPr>
+          <p:cNvPr id="3" name="TextBox 2"/>
+          <p:cNvSpPr txBox="1"/>
+          <p:nvPr/>
         </p:nvSpPr>
         <p:spPr>
           <a:xfrm>
-            <a:off x="4774063" y="2857500"/>
-            <a:ext cx="2643873" cy="1143000"/>
+            <a:off x="548640" y="1280160"/>
+            <a:ext cx="11094720" cy="5029200"/>
           </a:xfrm>
+          <a:prstGeom prst="rect">
+            <a:avLst/>
+          </a:prstGeom>
+          <a:noFill/>
         </p:spPr>
         <p:txBody>
-          <a:bodyPr/>
-          <a:lstStyle/>
-          <a:p>
-            <a:pPr algn="ctr"/>
-            <a:r>
-              <a:rPr lang="en-US" dirty="0"/>
-              <a:t>Thank You</a:t>
-            </a:r>
-            <a:endParaRPr dirty="0"/>
+          <a:bodyPr wrap="square">
+            <a:spAutoFit/>
+          </a:bodyPr>
+          <a:lstStyle/>
+          <a:p>
+            <a:r>
+              <a:rPr sz="1800"/>
+              <a:t>Duration (49% of riders in High band - largest population burden):</a:t>
+            </a:r>
+          </a:p>
+          <a:p>
+            <a:r>
+              <a:rPr sz="1600"/>
+              <a:t>   shift-length caps and mandatory breaks every 2 hours</a:t>
+            </a:r>
+          </a:p>
+          <a:p>
+            <a:r>
+              <a:rPr sz="1800"/>
+              <a:t/>
+            </a:r>
+          </a:p>
+          <a:p>
+            <a:r>
+              <a:rPr sz="1800"/>
+              <a:t>Force (only factor significantly associated with discomfort, p = 0.035):</a:t>
+            </a:r>
+          </a:p>
+          <a:p>
+            <a:r>
+              <a:rPr sz="1600"/>
+              <a:t>   limit carried-package weight; train safer lifting technique</a:t>
+            </a:r>
+          </a:p>
+          <a:p>
+            <a:r>
+              <a:rPr sz="1800"/>
+              <a:t/>
+            </a:r>
+          </a:p>
+          <a:p>
+            <a:r>
+              <a:rPr sz="1800"/>
+              <a:t>Contact Stress (handheld carriers reported less discomfort):</a:t>
+            </a:r>
+          </a:p>
+          <a:p>
+            <a:r>
+              <a:rPr sz="1600"/>
+              <a:t>   encourage bike-storage box or backpack over handheld delivery</a:t>
+            </a:r>
+          </a:p>
+          <a:p>
+            <a:r>
+              <a:rPr sz="1800"/>
+              <a:t/>
+            </a:r>
+          </a:p>
+          <a:p>
+            <a:r>
+              <a:rPr sz="1800"/>
+              <a:t>Age and job duration (strongest individual-level discomfort predictors):</a:t>
+            </a:r>
+          </a:p>
+          <a:p>
+            <a:r>
+              <a:rPr sz="1600"/>
+              <a:t>   workload tapering for riders over 12 months tenure or over 35 years old</a:t>
+            </a:r>
           </a:p>
         </p:txBody>
       </p:sp>
     </p:spTree>
-    <p:extLst>
-      <p:ext uri="{BB962C8B-B14F-4D97-AF65-F5344CB8AC3E}">
-        <p14:creationId xmlns:p14="http://schemas.microsoft.com/office/powerpoint/2010/main" val="2503925356"/>
-      </p:ext>
-    </p:extLst>
   </p:cSld>
   <p:clrMapOvr>
     <a:masterClrMapping/>

</xml_diff>

<commit_message>
Rebuild WITH_RESULTS.pptx after citation removal
</commit_message>
<xml_diff>
--- a/deck/Ergonomic_Risk_Factor_Prediction_Project_Plan_WITH_RESULTS.pptx
+++ b/deck/Ergonomic_Risk_Factor_Prediction_Project_Plan_WITH_RESULTS.pptx
@@ -9920,13 +9920,13 @@
           <a:p>
             <a:r>
               <a:rPr sz="1800"/>
-              <a:t>5 survey-derived factors land inside the 60-80% published survey-based band.</a:t>
+              <a:t>5 survey-derived factors land at 58-62% accuracy with macro AUC 71-76%.</a:t>
             </a:r>
           </a:p>
           <a:p>
             <a:r>
               <a:rPr sz="1800"/>
-              <a:t>Posture uses real RULA + QEC observation inputs and reaches sensor-based range.</a:t>
+              <a:t>Posture uses real RULA + QEC observation inputs and reaches 97% / AUC 98%.</a:t>
             </a:r>
           </a:p>
         </p:txBody>
@@ -10640,7 +10640,7 @@
           <a:lstStyle/>
           <a:p>
             <a:r>
-              <a:t>Comparison with published benchmarks</a:t>
+              <a:t>Per-factor positioning</a:t>
             </a:r>
           </a:p>
         </p:txBody>
@@ -10669,13 +10669,13 @@
           <a:p>
             <a:r>
               <a:rPr sz="1800"/>
-              <a:t>Survey-based MSD-prediction studies typically reach 60-80% accuracy</a:t>
+              <a:t>Survey-only inputs limit how high the 5 survey-derived models can go,</a:t>
             </a:r>
           </a:p>
           <a:p>
             <a:r>
               <a:rPr sz="1800"/>
-              <a:t>(Annals of Occupational and Environmental Medicine 2024, review of 130 studies).</a:t>
+              <a:t>because each model excludes the variable that defines its own target.</a:t>
             </a:r>
           </a:p>
           <a:p>
@@ -10687,13 +10687,7 @@
           <a:p>
             <a:r>
               <a:rPr sz="1800"/>
-              <a:t>Sensor-based studies (IMU / EMG / computer vision) reach 90-99% because</a:t>
-            </a:r>
-          </a:p>
-          <a:p>
-            <a:r>
-              <a:rPr sz="1800"/>
-              <a:t>the inputs are direct physical signals.</a:t>
+              <a:t>The 5 survey-derived factors land at 58-62% accuracy and macro AUC 71-76%.</a:t>
             </a:r>
           </a:p>
           <a:p>
@@ -10705,7 +10699,13 @@
           <a:p>
             <a:r>
               <a:rPr sz="1800"/>
-              <a:t>Our 5 survey-derived factors all land inside the survey-based band.</a:t>
+              <a:t>Macro AUC &gt; 0.70 means the models still rank riders correctly,</a:t>
+            </a:r>
+          </a:p>
+          <a:p>
+            <a:r>
+              <a:rPr sz="1800"/>
+              <a:t>even when they don't always predict the exact class.</a:t>
             </a:r>
           </a:p>
           <a:p>
@@ -10723,7 +10723,7 @@
           <a:p>
             <a:r>
               <a:rPr sz="1800"/>
-              <a:t>so it sits in the sensor-based range at 97% / AUC 98%.</a:t>
+              <a:t>so it reaches 97% / AUC 98%.</a:t>
             </a:r>
           </a:p>
         </p:txBody>
@@ -10791,7 +10791,7 @@
           <a:p>
             <a:r>
               <a:rPr sz="1800"/>
-              <a:t>1. n = 182 self-report sample. Cross-sectional, single-region (Tamil Nadu).</a:t>
+              <a:t>1. n = 182 self-report sample. Cross-sectional, single-region deployment.</a:t>
             </a:r>
           </a:p>
           <a:p>

</xml_diff>

<commit_message>
Update deck builder + rebuild WITH_RESULTS.pptx (53 -> 61 slides)
8 new slides added so the deck matches what's now in PROJECT_REPORT.docx:
- Pipeline overview (the new methodology_flowchart.png) inserted right
  after the Results & Findings section header
- Winning hyperparameters text slide listing what GridSearchCV settled
  on per target (matches Table 10 in the doc)
- New 'Live web demo' section header
- 5 web-app screenshot slides showing the form sections and the
  prediction output (the same images embedded as Figures 11-15 in the
  doc, read from outputs/app_screenshots/ via a new
  add_screenshot_slide helper)
</commit_message>
<xml_diff>
--- a/deck/Ergonomic_Risk_Factor_Prediction_Project_Plan_WITH_RESULTS.pptx
+++ b/deck/Ergonomic_Risk_Factor_Prediction_Project_Plan_WITH_RESULTS.pptx
@@ -57,6 +57,14 @@
     <p:sldId id="314" r:id="rId56"/>
     <p:sldId id="315" r:id="rId57"/>
     <p:sldId id="316" r:id="rId58"/>
+    <p:sldId id="317" r:id="rId59"/>
+    <p:sldId id="318" r:id="rId60"/>
+    <p:sldId id="319" r:id="rId61"/>
+    <p:sldId id="320" r:id="rId62"/>
+    <p:sldId id="321" r:id="rId63"/>
+    <p:sldId id="322" r:id="rId64"/>
+    <p:sldId id="323" r:id="rId65"/>
+    <p:sldId id="324" r:id="rId66"/>
     <p:sldId id="301" r:id="rId40"/>
   </p:sldIdLst>
   <p:sldSz cx="12192000" cy="6858000"/>
@@ -9343,6 +9351,98 @@
           <a:lstStyle/>
           <a:p>
             <a:r>
+              <a:t>Pipeline overview</a:t>
+            </a:r>
+          </a:p>
+        </p:txBody>
+      </p:sp>
+      <p:pic>
+        <p:nvPicPr>
+          <p:cNvPr id="3" name="Picture 2" descr="methodology_flowchart.png"/>
+          <p:cNvPicPr>
+            <a:picLocks noChangeAspect="1"/>
+          </p:cNvPicPr>
+          <p:nvPr/>
+        </p:nvPicPr>
+        <p:blipFill>
+          <a:blip r:embed="rId2"/>
+          <a:stretch>
+            <a:fillRect/>
+          </a:stretch>
+        </p:blipFill>
+        <p:spPr>
+          <a:xfrm>
+            <a:off x="1066800" y="1371600"/>
+            <a:ext cx="10058400" cy="3700955"/>
+          </a:xfrm>
+          <a:prstGeom prst="rect">
+            <a:avLst/>
+          </a:prstGeom>
+        </p:spPr>
+      </p:pic>
+      <p:sp>
+        <p:nvSpPr>
+          <p:cNvPr id="4" name="TextBox 3"/>
+          <p:cNvSpPr txBox="1"/>
+          <p:nvPr/>
+        </p:nvSpPr>
+        <p:spPr>
+          <a:xfrm>
+            <a:off x="457200" y="6126480"/>
+            <a:ext cx="11277600" cy="640080"/>
+          </a:xfrm>
+          <a:prstGeom prst="rect">
+            <a:avLst/>
+          </a:prstGeom>
+          <a:noFill/>
+        </p:spPr>
+        <p:txBody>
+          <a:bodyPr wrap="none">
+            <a:spAutoFit/>
+          </a:bodyPr>
+          <a:lstStyle/>
+          <a:p>
+            <a:r>
+              <a:rPr sz="1400" i="1"/>
+              <a:t>Raw inputs -&gt; cleaning -&gt; feature engineering -&gt; Stage 1 labels -&gt; Stage 2 ML -&gt; web app</a:t>
+            </a:r>
+          </a:p>
+        </p:txBody>
+      </p:sp>
+    </p:spTree>
+  </p:cSld>
+  <p:clrMapOvr>
+    <a:masterClrMapping/>
+  </p:clrMapOvr>
+</p:sld>
+</file>
+
+<file path=ppt/slides/slide42.xml><?xml version="1.0" encoding="utf-8"?>
+<p:sld xmlns:a="http://schemas.openxmlformats.org/drawingml/2006/main" xmlns:p="http://schemas.openxmlformats.org/presentationml/2006/main" xmlns:r="http://schemas.openxmlformats.org/officeDocument/2006/relationships">
+  <p:cSld>
+    <p:spTree>
+      <p:nvGrpSpPr>
+        <p:cNvPr id="1" name=""/>
+        <p:cNvGrpSpPr/>
+        <p:nvPr/>
+      </p:nvGrpSpPr>
+      <p:grpSpPr/>
+      <p:sp>
+        <p:nvSpPr>
+          <p:cNvPr id="2" name="Title 1"/>
+          <p:cNvSpPr>
+            <a:spLocks noGrp="1"/>
+          </p:cNvSpPr>
+          <p:nvPr>
+            <p:ph type="title"/>
+          </p:nvPr>
+        </p:nvSpPr>
+        <p:spPr/>
+        <p:txBody>
+          <a:bodyPr/>
+          <a:lstStyle/>
+          <a:p>
+            <a:r>
               <a:t>Sample demographics (n = 182)</a:t>
             </a:r>
           </a:p>
@@ -9380,7 +9480,7 @@
 </p:sld>
 </file>
 
-<file path=ppt/slides/slide42.xml><?xml version="1.0" encoding="utf-8"?>
+<file path=ppt/slides/slide43.xml><?xml version="1.0" encoding="utf-8"?>
 <p:sld xmlns:a="http://schemas.openxmlformats.org/drawingml/2006/main" xmlns:p="http://schemas.openxmlformats.org/presentationml/2006/main" xmlns:r="http://schemas.openxmlformats.org/officeDocument/2006/relationships">
   <p:cSld>
     <p:spTree>
@@ -9472,7 +9572,7 @@
 </p:sld>
 </file>
 
-<file path=ppt/slides/slide43.xml><?xml version="1.0" encoding="utf-8"?>
+<file path=ppt/slides/slide44.xml><?xml version="1.0" encoding="utf-8"?>
 <p:sld xmlns:a="http://schemas.openxmlformats.org/drawingml/2006/main" xmlns:p="http://schemas.openxmlformats.org/presentationml/2006/main" xmlns:r="http://schemas.openxmlformats.org/officeDocument/2006/relationships">
   <p:cSld>
     <p:spTree>
@@ -9535,7 +9635,7 @@
 </p:sld>
 </file>
 
-<file path=ppt/slides/slide44.xml><?xml version="1.0" encoding="utf-8"?>
+<file path=ppt/slides/slide45.xml><?xml version="1.0" encoding="utf-8"?>
 <p:sld xmlns:a="http://schemas.openxmlformats.org/drawingml/2006/main" xmlns:p="http://schemas.openxmlformats.org/presentationml/2006/main" xmlns:r="http://schemas.openxmlformats.org/officeDocument/2006/relationships">
   <p:cSld>
     <p:spTree>
@@ -9627,7 +9727,7 @@
 </p:sld>
 </file>
 
-<file path=ppt/slides/slide45.xml><?xml version="1.0" encoding="utf-8"?>
+<file path=ppt/slides/slide46.xml><?xml version="1.0" encoding="utf-8"?>
 <p:sld xmlns:a="http://schemas.openxmlformats.org/drawingml/2006/main" xmlns:p="http://schemas.openxmlformats.org/presentationml/2006/main" xmlns:r="http://schemas.openxmlformats.org/officeDocument/2006/relationships">
   <p:cSld>
     <p:spTree>
@@ -9719,7 +9819,7 @@
 </p:sld>
 </file>
 
-<file path=ppt/slides/slide46.xml><?xml version="1.0" encoding="utf-8"?>
+<file path=ppt/slides/slide47.xml><?xml version="1.0" encoding="utf-8"?>
 <p:sld xmlns:a="http://schemas.openxmlformats.org/drawingml/2006/main" xmlns:p="http://schemas.openxmlformats.org/presentationml/2006/main" xmlns:r="http://schemas.openxmlformats.org/officeDocument/2006/relationships">
   <p:cSld>
     <p:spTree>
@@ -9811,7 +9911,7 @@
 </p:sld>
 </file>
 
-<file path=ppt/slides/slide47.xml><?xml version="1.0" encoding="utf-8"?>
+<file path=ppt/slides/slide48.xml><?xml version="1.0" encoding="utf-8"?>
 <p:sld xmlns:a="http://schemas.openxmlformats.org/drawingml/2006/main" xmlns:p="http://schemas.openxmlformats.org/presentationml/2006/main" xmlns:r="http://schemas.openxmlformats.org/officeDocument/2006/relationships">
   <p:cSld>
     <p:spTree>
@@ -9931,69 +10031,6 @@
           </a:p>
         </p:txBody>
       </p:sp>
-    </p:spTree>
-  </p:cSld>
-  <p:clrMapOvr>
-    <a:masterClrMapping/>
-  </p:clrMapOvr>
-</p:sld>
-</file>
-
-<file path=ppt/slides/slide48.xml><?xml version="1.0" encoding="utf-8"?>
-<p:sld xmlns:a="http://schemas.openxmlformats.org/drawingml/2006/main" xmlns:p="http://schemas.openxmlformats.org/presentationml/2006/main" xmlns:r="http://schemas.openxmlformats.org/officeDocument/2006/relationships">
-  <p:cSld>
-    <p:spTree>
-      <p:nvGrpSpPr>
-        <p:cNvPr id="1" name=""/>
-        <p:cNvGrpSpPr/>
-        <p:nvPr/>
-      </p:nvGrpSpPr>
-      <p:grpSpPr/>
-      <p:sp>
-        <p:nvSpPr>
-          <p:cNvPr id="2" name="Title 1"/>
-          <p:cNvSpPr>
-            <a:spLocks noGrp="1"/>
-          </p:cNvSpPr>
-          <p:nvPr>
-            <p:ph type="title"/>
-          </p:nvPr>
-        </p:nvSpPr>
-        <p:spPr/>
-        <p:txBody>
-          <a:bodyPr/>
-          <a:lstStyle/>
-          <a:p>
-            <a:r>
-              <a:t>Confusion matrices (best model per factor)</a:t>
-            </a:r>
-          </a:p>
-        </p:txBody>
-      </p:sp>
-      <p:pic>
-        <p:nvPicPr>
-          <p:cNvPr id="3" name="Picture 2" descr="confusion_matrices.png"/>
-          <p:cNvPicPr>
-            <a:picLocks noChangeAspect="1"/>
-          </p:cNvPicPr>
-          <p:nvPr/>
-        </p:nvPicPr>
-        <p:blipFill>
-          <a:blip r:embed="rId2"/>
-          <a:stretch>
-            <a:fillRect/>
-          </a:stretch>
-        </p:blipFill>
-        <p:spPr>
-          <a:xfrm>
-            <a:off x="2335909" y="1371600"/>
-            <a:ext cx="7520181" cy="4572000"/>
-          </a:xfrm>
-          <a:prstGeom prst="rect">
-            <a:avLst/>
-          </a:prstGeom>
-        </p:spPr>
-      </p:pic>
     </p:spTree>
   </p:cSld>
   <p:clrMapOvr>
@@ -10028,45 +10065,21 @@
           <a:lstStyle/>
           <a:p>
             <a:r>
-              <a:t>ROC curves (one-vs-rest)</a:t>
-            </a:r>
-          </a:p>
-        </p:txBody>
-      </p:sp>
-      <p:pic>
-        <p:nvPicPr>
-          <p:cNvPr id="3" name="Picture 2" descr="roc_curves.png"/>
-          <p:cNvPicPr>
-            <a:picLocks noChangeAspect="1"/>
-          </p:cNvPicPr>
+              <a:t>Winning hyperparameters (GridSearchCV)</a:t>
+            </a:r>
+          </a:p>
+        </p:txBody>
+      </p:sp>
+      <p:sp>
+        <p:nvSpPr>
+          <p:cNvPr id="3" name="TextBox 2"/>
+          <p:cNvSpPr txBox="1"/>
           <p:nvPr/>
-        </p:nvPicPr>
-        <p:blipFill>
-          <a:blip r:embed="rId2"/>
-          <a:stretch>
-            <a:fillRect/>
-          </a:stretch>
-        </p:blipFill>
+        </p:nvSpPr>
         <p:spPr>
           <a:xfrm>
-            <a:off x="2340127" y="1371600"/>
-            <a:ext cx="7511745" cy="4572000"/>
-          </a:xfrm>
-          <a:prstGeom prst="rect">
-            <a:avLst/>
-          </a:prstGeom>
-        </p:spPr>
-      </p:pic>
-      <p:sp>
-        <p:nvSpPr>
-          <p:cNvPr id="4" name="TextBox 3"/>
-          <p:cNvSpPr txBox="1"/>
-          <p:nvPr/>
-        </p:nvSpPr>
-        <p:spPr>
-          <a:xfrm>
-            <a:off x="457200" y="6126480"/>
-            <a:ext cx="11277600" cy="640080"/>
+            <a:off x="548640" y="1280160"/>
+            <a:ext cx="11094720" cy="5029200"/>
           </a:xfrm>
           <a:prstGeom prst="rect">
             <a:avLst/>
@@ -10074,14 +10087,80 @@
           <a:noFill/>
         </p:spPr>
         <p:txBody>
-          <a:bodyPr wrap="none">
+          <a:bodyPr wrap="square">
             <a:spAutoFit/>
           </a:bodyPr>
           <a:lstStyle/>
           <a:p>
             <a:r>
-              <a:rPr sz="1400" i="1"/>
-              <a:t>AUC &gt; 0.70 for 5 of 6 factors</a:t>
+              <a:rPr sz="1800"/>
+              <a:t>The values each target's grid search settled on:</a:t>
+            </a:r>
+          </a:p>
+          <a:p>
+            <a:r>
+              <a:rPr sz="1800"/>
+              <a:t/>
+            </a:r>
+          </a:p>
+          <a:p>
+            <a:r>
+              <a:rPr sz="1800"/>
+              <a:t>Force           HistGradientBoosting    max_depth=None,  learning_rate=0.05</a:t>
+            </a:r>
+          </a:p>
+          <a:p>
+            <a:r>
+              <a:rPr sz="1800"/>
+              <a:t>Repetition      Random Forest           n_estimators=300, max_depth=None</a:t>
+            </a:r>
+          </a:p>
+          <a:p>
+            <a:r>
+              <a:rPr sz="1800"/>
+              <a:t>Duration        Random Forest           n_estimators=500, max_depth=5</a:t>
+            </a:r>
+          </a:p>
+          <a:p>
+            <a:r>
+              <a:rPr sz="1800"/>
+              <a:t>Vibration       Extra Trees             n_estimators=300, max_depth=None</a:t>
+            </a:r>
+          </a:p>
+          <a:p>
+            <a:r>
+              <a:rPr sz="1800"/>
+              <a:t>Contact Stress  Random Forest           n_estimators=500, max_depth=None</a:t>
+            </a:r>
+          </a:p>
+          <a:p>
+            <a:r>
+              <a:rPr sz="1800"/>
+              <a:t>Posture         HistGradientBoosting    max_depth=5,     learning_rate=0.05</a:t>
+            </a:r>
+          </a:p>
+          <a:p>
+            <a:r>
+              <a:rPr sz="1800"/>
+              <a:t/>
+            </a:r>
+          </a:p>
+          <a:p>
+            <a:r>
+              <a:rPr sz="1800"/>
+              <a:t>SMOTE k_neighbors = 5 for every target.</a:t>
+            </a:r>
+          </a:p>
+          <a:p>
+            <a:r>
+              <a:rPr sz="1800"/>
+              <a:t>All pipelines: imblearn.Pipeline([SMOTE, classifier]).</a:t>
+            </a:r>
+          </a:p>
+          <a:p>
+            <a:r>
+              <a:rPr sz="1800"/>
+              <a:t>All CV folds: StratifiedKFold(5, shuffle=True, random_state=42).</a:t>
             </a:r>
           </a:p>
         </p:txBody>
@@ -10548,6 +10627,161 @@
           <a:lstStyle/>
           <a:p>
             <a:r>
+              <a:t>Confusion matrices (best model per factor)</a:t>
+            </a:r>
+          </a:p>
+        </p:txBody>
+      </p:sp>
+      <p:pic>
+        <p:nvPicPr>
+          <p:cNvPr id="3" name="Picture 2" descr="confusion_matrices.png"/>
+          <p:cNvPicPr>
+            <a:picLocks noChangeAspect="1"/>
+          </p:cNvPicPr>
+          <p:nvPr/>
+        </p:nvPicPr>
+        <p:blipFill>
+          <a:blip r:embed="rId2"/>
+          <a:stretch>
+            <a:fillRect/>
+          </a:stretch>
+        </p:blipFill>
+        <p:spPr>
+          <a:xfrm>
+            <a:off x="2335909" y="1371600"/>
+            <a:ext cx="7520181" cy="4572000"/>
+          </a:xfrm>
+          <a:prstGeom prst="rect">
+            <a:avLst/>
+          </a:prstGeom>
+        </p:spPr>
+      </p:pic>
+    </p:spTree>
+  </p:cSld>
+  <p:clrMapOvr>
+    <a:masterClrMapping/>
+  </p:clrMapOvr>
+</p:sld>
+</file>
+
+<file path=ppt/slides/slide51.xml><?xml version="1.0" encoding="utf-8"?>
+<p:sld xmlns:a="http://schemas.openxmlformats.org/drawingml/2006/main" xmlns:p="http://schemas.openxmlformats.org/presentationml/2006/main" xmlns:r="http://schemas.openxmlformats.org/officeDocument/2006/relationships">
+  <p:cSld>
+    <p:spTree>
+      <p:nvGrpSpPr>
+        <p:cNvPr id="1" name=""/>
+        <p:cNvGrpSpPr/>
+        <p:nvPr/>
+      </p:nvGrpSpPr>
+      <p:grpSpPr/>
+      <p:sp>
+        <p:nvSpPr>
+          <p:cNvPr id="2" name="Title 1"/>
+          <p:cNvSpPr>
+            <a:spLocks noGrp="1"/>
+          </p:cNvSpPr>
+          <p:nvPr>
+            <p:ph type="title"/>
+          </p:nvPr>
+        </p:nvSpPr>
+        <p:spPr/>
+        <p:txBody>
+          <a:bodyPr/>
+          <a:lstStyle/>
+          <a:p>
+            <a:r>
+              <a:t>ROC curves (one-vs-rest)</a:t>
+            </a:r>
+          </a:p>
+        </p:txBody>
+      </p:sp>
+      <p:pic>
+        <p:nvPicPr>
+          <p:cNvPr id="3" name="Picture 2" descr="roc_curves.png"/>
+          <p:cNvPicPr>
+            <a:picLocks noChangeAspect="1"/>
+          </p:cNvPicPr>
+          <p:nvPr/>
+        </p:nvPicPr>
+        <p:blipFill>
+          <a:blip r:embed="rId2"/>
+          <a:stretch>
+            <a:fillRect/>
+          </a:stretch>
+        </p:blipFill>
+        <p:spPr>
+          <a:xfrm>
+            <a:off x="2340127" y="1371600"/>
+            <a:ext cx="7511745" cy="4572000"/>
+          </a:xfrm>
+          <a:prstGeom prst="rect">
+            <a:avLst/>
+          </a:prstGeom>
+        </p:spPr>
+      </p:pic>
+      <p:sp>
+        <p:nvSpPr>
+          <p:cNvPr id="4" name="TextBox 3"/>
+          <p:cNvSpPr txBox="1"/>
+          <p:nvPr/>
+        </p:nvSpPr>
+        <p:spPr>
+          <a:xfrm>
+            <a:off x="457200" y="6126480"/>
+            <a:ext cx="11277600" cy="640080"/>
+          </a:xfrm>
+          <a:prstGeom prst="rect">
+            <a:avLst/>
+          </a:prstGeom>
+          <a:noFill/>
+        </p:spPr>
+        <p:txBody>
+          <a:bodyPr wrap="none">
+            <a:spAutoFit/>
+          </a:bodyPr>
+          <a:lstStyle/>
+          <a:p>
+            <a:r>
+              <a:rPr sz="1400" i="1"/>
+              <a:t>AUC &gt; 0.70 for 5 of 6 factors</a:t>
+            </a:r>
+          </a:p>
+        </p:txBody>
+      </p:sp>
+    </p:spTree>
+  </p:cSld>
+  <p:clrMapOvr>
+    <a:masterClrMapping/>
+  </p:clrMapOvr>
+</p:sld>
+</file>
+
+<file path=ppt/slides/slide52.xml><?xml version="1.0" encoding="utf-8"?>
+<p:sld xmlns:a="http://schemas.openxmlformats.org/drawingml/2006/main" xmlns:p="http://schemas.openxmlformats.org/presentationml/2006/main" xmlns:r="http://schemas.openxmlformats.org/officeDocument/2006/relationships">
+  <p:cSld>
+    <p:spTree>
+      <p:nvGrpSpPr>
+        <p:cNvPr id="1" name=""/>
+        <p:cNvGrpSpPr/>
+        <p:nvPr/>
+      </p:nvGrpSpPr>
+      <p:grpSpPr/>
+      <p:sp>
+        <p:nvSpPr>
+          <p:cNvPr id="2" name="Title 1"/>
+          <p:cNvSpPr>
+            <a:spLocks noGrp="1"/>
+          </p:cNvSpPr>
+          <p:nvPr>
+            <p:ph type="title"/>
+          </p:nvPr>
+        </p:nvSpPr>
+        <p:spPr/>
+        <p:txBody>
+          <a:bodyPr/>
+          <a:lstStyle/>
+          <a:p>
+            <a:r>
               <a:t>Top features per model</a:t>
             </a:r>
           </a:p>
@@ -10614,7 +10848,7 @@
 </p:sld>
 </file>
 
-<file path=ppt/slides/slide51.xml><?xml version="1.0" encoding="utf-8"?>
+<file path=ppt/slides/slide53.xml><?xml version="1.0" encoding="utf-8"?>
 <p:sld xmlns:a="http://schemas.openxmlformats.org/drawingml/2006/main" xmlns:p="http://schemas.openxmlformats.org/presentationml/2006/main" xmlns:r="http://schemas.openxmlformats.org/officeDocument/2006/relationships">
   <p:cSld>
     <p:spTree>
@@ -10736,7 +10970,7 @@
 </p:sld>
 </file>
 
-<file path=ppt/slides/slide52.xml><?xml version="1.0" encoding="utf-8"?>
+<file path=ppt/slides/slide54.xml><?xml version="1.0" encoding="utf-8"?>
 <p:sld xmlns:a="http://schemas.openxmlformats.org/drawingml/2006/main" xmlns:p="http://schemas.openxmlformats.org/presentationml/2006/main" xmlns:r="http://schemas.openxmlformats.org/officeDocument/2006/relationships">
   <p:cSld>
     <p:spTree>
@@ -10888,7 +11122,7 @@
 </p:sld>
 </file>
 
-<file path=ppt/slides/slide53.xml><?xml version="1.0" encoding="utf-8"?>
+<file path=ppt/slides/slide55.xml><?xml version="1.0" encoding="utf-8"?>
 <p:sld xmlns:a="http://schemas.openxmlformats.org/drawingml/2006/main" xmlns:p="http://schemas.openxmlformats.org/presentationml/2006/main" xmlns:r="http://schemas.openxmlformats.org/officeDocument/2006/relationships">
   <p:cSld>
     <p:spTree>
@@ -11004,6 +11238,313 @@
             <a:r>
               <a:rPr sz="1600"/>
               <a:t>   workload tapering for riders over 12 months tenure or over 35 years old</a:t>
+            </a:r>
+          </a:p>
+        </p:txBody>
+      </p:sp>
+    </p:spTree>
+  </p:cSld>
+  <p:clrMapOvr>
+    <a:masterClrMapping/>
+  </p:clrMapOvr>
+</p:sld>
+</file>
+
+<file path=ppt/slides/slide56.xml><?xml version="1.0" encoding="utf-8"?>
+<p:sld xmlns:a="http://schemas.openxmlformats.org/drawingml/2006/main" xmlns:p="http://schemas.openxmlformats.org/presentationml/2006/main" xmlns:r="http://schemas.openxmlformats.org/officeDocument/2006/relationships">
+  <p:cSld>
+    <p:spTree>
+      <p:nvGrpSpPr>
+        <p:cNvPr id="1" name=""/>
+        <p:cNvGrpSpPr/>
+        <p:nvPr/>
+      </p:nvGrpSpPr>
+      <p:grpSpPr/>
+      <p:sp>
+        <p:nvSpPr>
+          <p:cNvPr id="2" name="Title 1"/>
+          <p:cNvSpPr>
+            <a:spLocks noGrp="1"/>
+          </p:cNvSpPr>
+          <p:nvPr>
+            <p:ph type="title"/>
+          </p:nvPr>
+        </p:nvSpPr>
+        <p:spPr/>
+        <p:txBody>
+          <a:bodyPr/>
+          <a:lstStyle/>
+          <a:p>
+            <a:r>
+              <a:t>Live web demo</a:t>
+            </a:r>
+          </a:p>
+        </p:txBody>
+      </p:sp>
+      <p:sp>
+        <p:nvSpPr>
+          <p:cNvPr id="3" name="Text Placeholder 2"/>
+          <p:cNvSpPr>
+            <a:spLocks noGrp="1"/>
+          </p:cNvSpPr>
+          <p:nvPr>
+            <p:ph type="body" idx="1"/>
+          </p:nvPr>
+        </p:nvSpPr>
+        <p:spPr/>
+        <p:txBody>
+          <a:bodyPr/>
+          <a:lstStyle/>
+          <a:p>
+            <a:r>
+              <a:t>Streamlit screening tool: full questionnaire to per-factor risk levels</a:t>
+            </a:r>
+          </a:p>
+        </p:txBody>
+      </p:sp>
+    </p:spTree>
+  </p:cSld>
+  <p:clrMapOvr>
+    <a:masterClrMapping/>
+  </p:clrMapOvr>
+</p:sld>
+</file>
+
+<file path=ppt/slides/slide57.xml><?xml version="1.0" encoding="utf-8"?>
+<p:sld xmlns:a="http://schemas.openxmlformats.org/drawingml/2006/main" xmlns:p="http://schemas.openxmlformats.org/presentationml/2006/main" xmlns:r="http://schemas.openxmlformats.org/officeDocument/2006/relationships">
+  <p:cSld>
+    <p:spTree>
+      <p:nvGrpSpPr>
+        <p:cNvPr id="1" name=""/>
+        <p:cNvGrpSpPr/>
+        <p:nvPr/>
+      </p:nvGrpSpPr>
+      <p:grpSpPr/>
+      <p:sp>
+        <p:nvSpPr>
+          <p:cNvPr id="2" name="Title 1"/>
+          <p:cNvSpPr>
+            <a:spLocks noGrp="1"/>
+          </p:cNvSpPr>
+          <p:nvPr>
+            <p:ph type="title"/>
+          </p:nvPr>
+        </p:nvSpPr>
+        <p:spPr/>
+        <p:txBody>
+          <a:bodyPr/>
+          <a:lstStyle/>
+          <a:p>
+            <a:r>
+              <a:t>Web app: header and demographic (Q1-17)</a:t>
+            </a:r>
+          </a:p>
+        </p:txBody>
+      </p:sp>
+      <p:pic>
+        <p:nvPicPr>
+          <p:cNvPr id="3" name="Picture 2" descr="web_01_header_demographic.png"/>
+          <p:cNvPicPr>
+            <a:picLocks noChangeAspect="1"/>
+          </p:cNvPicPr>
+          <p:nvPr/>
+        </p:nvPicPr>
+        <p:blipFill>
+          <a:blip r:embed="rId2"/>
+          <a:stretch>
+            <a:fillRect/>
+          </a:stretch>
+        </p:blipFill>
+        <p:spPr>
+          <a:xfrm>
+            <a:off x="2245895" y="1371600"/>
+            <a:ext cx="7700210" cy="4572000"/>
+          </a:xfrm>
+          <a:prstGeom prst="rect">
+            <a:avLst/>
+          </a:prstGeom>
+        </p:spPr>
+      </p:pic>
+      <p:sp>
+        <p:nvSpPr>
+          <p:cNvPr id="4" name="TextBox 3"/>
+          <p:cNvSpPr txBox="1"/>
+          <p:nvPr/>
+        </p:nvSpPr>
+        <p:spPr>
+          <a:xfrm>
+            <a:off x="457200" y="6126480"/>
+            <a:ext cx="11277600" cy="640080"/>
+          </a:xfrm>
+          <a:prstGeom prst="rect">
+            <a:avLst/>
+          </a:prstGeom>
+          <a:noFill/>
+        </p:spPr>
+        <p:txBody>
+          <a:bodyPr wrap="none">
+            <a:spAutoFit/>
+          </a:bodyPr>
+          <a:lstStyle/>
+          <a:p>
+            <a:r>
+              <a:rPr sz="1400" i="1"/>
+              <a:t>Sample-profile shortcuts let the mentor try Low / Average / High risk presets in one click</a:t>
+            </a:r>
+          </a:p>
+        </p:txBody>
+      </p:sp>
+    </p:spTree>
+  </p:cSld>
+  <p:clrMapOvr>
+    <a:masterClrMapping/>
+  </p:clrMapOvr>
+</p:sld>
+</file>
+
+<file path=ppt/slides/slide58.xml><?xml version="1.0" encoding="utf-8"?>
+<p:sld xmlns:a="http://schemas.openxmlformats.org/drawingml/2006/main" xmlns:p="http://schemas.openxmlformats.org/presentationml/2006/main" xmlns:r="http://schemas.openxmlformats.org/officeDocument/2006/relationships">
+  <p:cSld>
+    <p:spTree>
+      <p:nvGrpSpPr>
+        <p:cNvPr id="1" name=""/>
+        <p:cNvGrpSpPr/>
+        <p:nvPr/>
+      </p:nvGrpSpPr>
+      <p:grpSpPr/>
+      <p:sp>
+        <p:nvSpPr>
+          <p:cNvPr id="2" name="Title 1"/>
+          <p:cNvSpPr>
+            <a:spLocks noGrp="1"/>
+          </p:cNvSpPr>
+          <p:nvPr>
+            <p:ph type="title"/>
+          </p:nvPr>
+        </p:nvSpPr>
+        <p:spPr/>
+        <p:txBody>
+          <a:bodyPr/>
+          <a:lstStyle/>
+          <a:p>
+            <a:r>
+              <a:t>Web app: Nordic + 7-day + outcomes (Q18-24)</a:t>
+            </a:r>
+          </a:p>
+        </p:txBody>
+      </p:sp>
+      <p:pic>
+        <p:nvPicPr>
+          <p:cNvPr id="3" name="Picture 2" descr="web_02_nmq.png"/>
+          <p:cNvPicPr>
+            <a:picLocks noChangeAspect="1"/>
+          </p:cNvPicPr>
+          <p:nvPr/>
+        </p:nvPicPr>
+        <p:blipFill>
+          <a:blip r:embed="rId2"/>
+          <a:stretch>
+            <a:fillRect/>
+          </a:stretch>
+        </p:blipFill>
+        <p:spPr>
+          <a:xfrm>
+            <a:off x="2245895" y="1371600"/>
+            <a:ext cx="7700210" cy="4572000"/>
+          </a:xfrm>
+          <a:prstGeom prst="rect">
+            <a:avLst/>
+          </a:prstGeom>
+        </p:spPr>
+      </p:pic>
+    </p:spTree>
+  </p:cSld>
+  <p:clrMapOvr>
+    <a:masterClrMapping/>
+  </p:clrMapOvr>
+</p:sld>
+</file>
+
+<file path=ppt/slides/slide59.xml><?xml version="1.0" encoding="utf-8"?>
+<p:sld xmlns:a="http://schemas.openxmlformats.org/drawingml/2006/main" xmlns:p="http://schemas.openxmlformats.org/presentationml/2006/main" xmlns:r="http://schemas.openxmlformats.org/officeDocument/2006/relationships">
+  <p:cSld>
+    <p:spTree>
+      <p:nvGrpSpPr>
+        <p:cNvPr id="1" name=""/>
+        <p:cNvGrpSpPr/>
+        <p:nvPr/>
+      </p:nvGrpSpPr>
+      <p:grpSpPr/>
+      <p:sp>
+        <p:nvSpPr>
+          <p:cNvPr id="2" name="Title 1"/>
+          <p:cNvSpPr>
+            <a:spLocks noGrp="1"/>
+          </p:cNvSpPr>
+          <p:nvPr>
+            <p:ph type="title"/>
+          </p:nvPr>
+        </p:nvSpPr>
+        <p:spPr/>
+        <p:txBody>
+          <a:bodyPr/>
+          <a:lstStyle/>
+          <a:p>
+            <a:r>
+              <a:t>Web app: NASA-TLX + Borg CR10 (Q25-36)</a:t>
+            </a:r>
+          </a:p>
+        </p:txBody>
+      </p:sp>
+      <p:pic>
+        <p:nvPicPr>
+          <p:cNvPr id="3" name="Picture 2" descr="web_03_nasa_borg.png"/>
+          <p:cNvPicPr>
+            <a:picLocks noChangeAspect="1"/>
+          </p:cNvPicPr>
+          <p:nvPr/>
+        </p:nvPicPr>
+        <p:blipFill>
+          <a:blip r:embed="rId2"/>
+          <a:stretch>
+            <a:fillRect/>
+          </a:stretch>
+        </p:blipFill>
+        <p:spPr>
+          <a:xfrm>
+            <a:off x="2245895" y="1371600"/>
+            <a:ext cx="7700210" cy="4572000"/>
+          </a:xfrm>
+          <a:prstGeom prst="rect">
+            <a:avLst/>
+          </a:prstGeom>
+        </p:spPr>
+      </p:pic>
+      <p:sp>
+        <p:nvSpPr>
+          <p:cNvPr id="4" name="TextBox 3"/>
+          <p:cNvSpPr txBox="1"/>
+          <p:nvPr/>
+        </p:nvSpPr>
+        <p:spPr>
+          <a:xfrm>
+            <a:off x="457200" y="6126480"/>
+            <a:ext cx="11277600" cy="640080"/>
+          </a:xfrm>
+          <a:prstGeom prst="rect">
+            <a:avLst/>
+          </a:prstGeom>
+          <a:noFill/>
+        </p:spPr>
+        <p:txBody>
+          <a:bodyPr wrap="none">
+            <a:spAutoFit/>
+          </a:bodyPr>
+          <a:lstStyle/>
+          <a:p>
+            <a:r>
+              <a:rPr sz="1400" i="1"/>
+              <a:t>All six NASA-TLX sliders point in load-direction (Q28 reworded as 'dissatisfied')</a:t>
             </a:r>
           </a:p>
         </p:txBody>
@@ -11318,6 +11859,190 @@
         <p14:creationId xmlns:p14="http://schemas.microsoft.com/office/powerpoint/2010/main" val="1572308069"/>
       </p:ext>
     </p:extLst>
+  </p:cSld>
+  <p:clrMapOvr>
+    <a:masterClrMapping/>
+  </p:clrMapOvr>
+</p:sld>
+</file>
+
+<file path=ppt/slides/slide60.xml><?xml version="1.0" encoding="utf-8"?>
+<p:sld xmlns:a="http://schemas.openxmlformats.org/drawingml/2006/main" xmlns:p="http://schemas.openxmlformats.org/presentationml/2006/main" xmlns:r="http://schemas.openxmlformats.org/officeDocument/2006/relationships">
+  <p:cSld>
+    <p:spTree>
+      <p:nvGrpSpPr>
+        <p:cNvPr id="1" name=""/>
+        <p:cNvGrpSpPr/>
+        <p:nvPr/>
+      </p:nvGrpSpPr>
+      <p:grpSpPr/>
+      <p:sp>
+        <p:nvSpPr>
+          <p:cNvPr id="2" name="Title 1"/>
+          <p:cNvSpPr>
+            <a:spLocks noGrp="1"/>
+          </p:cNvSpPr>
+          <p:nvPr>
+            <p:ph type="title"/>
+          </p:nvPr>
+        </p:nvSpPr>
+        <p:spPr/>
+        <p:txBody>
+          <a:bodyPr/>
+          <a:lstStyle/>
+          <a:p>
+            <a:r>
+              <a:t>Web app: RULA + QEC + Predict button</a:t>
+            </a:r>
+          </a:p>
+        </p:txBody>
+      </p:sp>
+      <p:pic>
+        <p:nvPicPr>
+          <p:cNvPr id="3" name="Picture 2" descr="web_04_rula_qec.png"/>
+          <p:cNvPicPr>
+            <a:picLocks noChangeAspect="1"/>
+          </p:cNvPicPr>
+          <p:nvPr/>
+        </p:nvPicPr>
+        <p:blipFill>
+          <a:blip r:embed="rId2"/>
+          <a:stretch>
+            <a:fillRect/>
+          </a:stretch>
+        </p:blipFill>
+        <p:spPr>
+          <a:xfrm>
+            <a:off x="2245895" y="1371600"/>
+            <a:ext cx="7700210" cy="4572000"/>
+          </a:xfrm>
+          <a:prstGeom prst="rect">
+            <a:avLst/>
+          </a:prstGeom>
+        </p:spPr>
+      </p:pic>
+      <p:sp>
+        <p:nvSpPr>
+          <p:cNvPr id="4" name="TextBox 3"/>
+          <p:cNvSpPr txBox="1"/>
+          <p:nvPr/>
+        </p:nvSpPr>
+        <p:spPr>
+          <a:xfrm>
+            <a:off x="457200" y="6126480"/>
+            <a:ext cx="11277600" cy="640080"/>
+          </a:xfrm>
+          <a:prstGeom prst="rect">
+            <a:avLst/>
+          </a:prstGeom>
+          <a:noFill/>
+        </p:spPr>
+        <p:txBody>
+          <a:bodyPr wrap="none">
+            <a:spAutoFit/>
+          </a:bodyPr>
+          <a:lstStyle/>
+          <a:p>
+            <a:r>
+              <a:rPr sz="1400" i="1"/>
+              <a:t>11 RULA components and 8 QEC scores drive the Posture model directly</a:t>
+            </a:r>
+          </a:p>
+        </p:txBody>
+      </p:sp>
+    </p:spTree>
+  </p:cSld>
+  <p:clrMapOvr>
+    <a:masterClrMapping/>
+  </p:clrMapOvr>
+</p:sld>
+</file>
+
+<file path=ppt/slides/slide61.xml><?xml version="1.0" encoding="utf-8"?>
+<p:sld xmlns:a="http://schemas.openxmlformats.org/drawingml/2006/main" xmlns:p="http://schemas.openxmlformats.org/presentationml/2006/main" xmlns:r="http://schemas.openxmlformats.org/officeDocument/2006/relationships">
+  <p:cSld>
+    <p:spTree>
+      <p:nvGrpSpPr>
+        <p:cNvPr id="1" name=""/>
+        <p:cNvGrpSpPr/>
+        <p:nvPr/>
+      </p:nvGrpSpPr>
+      <p:grpSpPr/>
+      <p:sp>
+        <p:nvSpPr>
+          <p:cNvPr id="2" name="Title 1"/>
+          <p:cNvSpPr>
+            <a:spLocks noGrp="1"/>
+          </p:cNvSpPr>
+          <p:nvPr>
+            <p:ph type="title"/>
+          </p:nvPr>
+        </p:nvSpPr>
+        <p:spPr/>
+        <p:txBody>
+          <a:bodyPr/>
+          <a:lstStyle/>
+          <a:p>
+            <a:r>
+              <a:t>Web app: predicted risk profile</a:t>
+            </a:r>
+          </a:p>
+        </p:txBody>
+      </p:sp>
+      <p:pic>
+        <p:nvPicPr>
+          <p:cNvPr id="3" name="Picture 2" descr="web_05_prediction_output.png"/>
+          <p:cNvPicPr>
+            <a:picLocks noChangeAspect="1"/>
+          </p:cNvPicPr>
+          <p:nvPr/>
+        </p:nvPicPr>
+        <p:blipFill>
+          <a:blip r:embed="rId2"/>
+          <a:stretch>
+            <a:fillRect/>
+          </a:stretch>
+        </p:blipFill>
+        <p:spPr>
+          <a:xfrm>
+            <a:off x="2245895" y="1371600"/>
+            <a:ext cx="7700210" cy="4572000"/>
+          </a:xfrm>
+          <a:prstGeom prst="rect">
+            <a:avLst/>
+          </a:prstGeom>
+        </p:spPr>
+      </p:pic>
+      <p:sp>
+        <p:nvSpPr>
+          <p:cNvPr id="4" name="TextBox 3"/>
+          <p:cNvSpPr txBox="1"/>
+          <p:nvPr/>
+        </p:nvSpPr>
+        <p:spPr>
+          <a:xfrm>
+            <a:off x="457200" y="6126480"/>
+            <a:ext cx="11277600" cy="640080"/>
+          </a:xfrm>
+          <a:prstGeom prst="rect">
+            <a:avLst/>
+          </a:prstGeom>
+          <a:noFill/>
+        </p:spPr>
+        <p:txBody>
+          <a:bodyPr wrap="none">
+            <a:spAutoFit/>
+          </a:bodyPr>
+          <a:lstStyle/>
+          <a:p>
+            <a:r>
+              <a:rPr sz="1400" i="1"/>
+              <a:t>Colour-coded bars, summary banner, and per-factor recommendations</a:t>
+            </a:r>
+          </a:p>
+        </p:txBody>
+      </p:sp>
+    </p:spTree>
   </p:cSld>
   <p:clrMapOvr>
     <a:masterClrMapping/>

</xml_diff>